<commit_message>
Update PPTX: add 学習院大学 to GMARCH definition, add university definition slide
</commit_message>
<xml_diff>
--- a/上位校採用分析レポート_2026_v2.pptx
+++ b/上位校採用分析レポート_2026_v2.pptx
@@ -13,6 +13,7 @@
     <p:sldId id="261" r:id="rId12"/>
     <p:sldId id="262" r:id="rId13"/>
     <p:sldId id="263" r:id="rId14"/>
+    <p:sldId id="264" r:id="rId15"/>
   </p:sldIdLst>
   <p:sldSz cx="12193200" cy="6858000" type="screen4x3"/>
   <p:notesSz cx="6858000" cy="9144000"/>
@@ -3246,7 +3247,7 @@
                 </a:solidFill>
                 <a:latin typeface="IPAゴシック"/>
               </a:rPr>
-              <a:t>対象期間：2026年1月〜7月　GMARCH・関関同立以上</a:t>
+              <a:t>対象期間：2026年1月〜7月　GMARCH以上（上位校）</a:t>
             </a:r>
           </a:p>
         </p:txBody>
@@ -3711,6 +3712,2295 @@
 </file>
 
 <file path=ppt/slides/slide2.xml><?xml version="1.0" encoding="utf-8"?>
+<p:sld xmlns:a="http://schemas.openxmlformats.org/drawingml/2006/main" xmlns:p="http://schemas.openxmlformats.org/presentationml/2006/main" xmlns:r="http://schemas.openxmlformats.org/officeDocument/2006/relationships">
+  <p:cSld>
+    <p:spTree>
+      <p:nvGrpSpPr>
+        <p:cNvPr id="1" name=""/>
+        <p:cNvGrpSpPr/>
+        <p:nvPr/>
+      </p:nvGrpSpPr>
+      <p:grpSpPr/>
+      <p:sp>
+        <p:nvSpPr>
+          <p:cNvPr id="2" name="Rectangle 1"/>
+          <p:cNvSpPr/>
+          <p:nvPr/>
+        </p:nvSpPr>
+        <p:spPr>
+          <a:xfrm>
+            <a:off x="0" y="0"/>
+            <a:ext cx="12193200" cy="6858000"/>
+          </a:xfrm>
+          <a:prstGeom prst="rect">
+            <a:avLst/>
+          </a:prstGeom>
+          <a:solidFill>
+            <a:srgbClr val="F4F6FB"/>
+          </a:solidFill>
+          <a:ln>
+            <a:noFill/>
+          </a:ln>
+        </p:spPr>
+        <p:style>
+          <a:lnRef idx="1">
+            <a:schemeClr val="accent1"/>
+          </a:lnRef>
+          <a:fillRef idx="3">
+            <a:schemeClr val="accent1"/>
+          </a:fillRef>
+          <a:effectRef idx="2">
+            <a:schemeClr val="accent1"/>
+          </a:effectRef>
+          <a:fontRef idx="minor">
+            <a:schemeClr val="lt1"/>
+          </a:fontRef>
+        </p:style>
+        <p:txBody>
+          <a:bodyPr rtlCol="0" anchor="ctr"/>
+          <a:lstStyle/>
+          <a:p>
+            <a:pPr algn="ctr"/>
+          </a:p>
+        </p:txBody>
+      </p:sp>
+      <p:sp>
+        <p:nvSpPr>
+          <p:cNvPr id="3" name="Rectangle 2"/>
+          <p:cNvSpPr/>
+          <p:nvPr/>
+        </p:nvSpPr>
+        <p:spPr>
+          <a:xfrm>
+            <a:off x="0" y="0"/>
+            <a:ext cx="12193200" cy="792000"/>
+          </a:xfrm>
+          <a:prstGeom prst="rect">
+            <a:avLst/>
+          </a:prstGeom>
+          <a:solidFill>
+            <a:srgbClr val="1F3564"/>
+          </a:solidFill>
+          <a:ln>
+            <a:noFill/>
+          </a:ln>
+        </p:spPr>
+        <p:style>
+          <a:lnRef idx="1">
+            <a:schemeClr val="accent1"/>
+          </a:lnRef>
+          <a:fillRef idx="3">
+            <a:schemeClr val="accent1"/>
+          </a:fillRef>
+          <a:effectRef idx="2">
+            <a:schemeClr val="accent1"/>
+          </a:effectRef>
+          <a:fontRef idx="minor">
+            <a:schemeClr val="lt1"/>
+          </a:fontRef>
+        </p:style>
+        <p:txBody>
+          <a:bodyPr rtlCol="0" anchor="ctr"/>
+          <a:lstStyle/>
+          <a:p>
+            <a:pPr algn="ctr"/>
+          </a:p>
+        </p:txBody>
+      </p:sp>
+      <p:sp>
+        <p:nvSpPr>
+          <p:cNvPr id="4" name="TextBox 3"/>
+          <p:cNvSpPr txBox="1"/>
+          <p:nvPr/>
+        </p:nvSpPr>
+        <p:spPr>
+          <a:xfrm>
+            <a:off x="180000" y="0"/>
+            <a:ext cx="11833200" cy="792000"/>
+          </a:xfrm>
+          <a:prstGeom prst="rect">
+            <a:avLst/>
+          </a:prstGeom>
+          <a:noFill/>
+        </p:spPr>
+        <p:txBody>
+          <a:bodyPr wrap="none">
+            <a:spAutoFit/>
+          </a:bodyPr>
+          <a:lstStyle/>
+          <a:p>
+            <a:pPr algn="ctr"/>
+            <a:r>
+              <a:rPr sz="2600" b="1">
+                <a:solidFill>
+                  <a:srgbClr val="FFFFFF"/>
+                </a:solidFill>
+                <a:latin typeface="IPAゴシック"/>
+              </a:rPr>
+              <a:t>上位校 定義一覧（GMARCH以上）</a:t>
+            </a:r>
+          </a:p>
+        </p:txBody>
+      </p:sp>
+      <p:sp>
+        <p:nvSpPr>
+          <p:cNvPr id="5" name="Rectangle 4"/>
+          <p:cNvSpPr/>
+          <p:nvPr/>
+        </p:nvSpPr>
+        <p:spPr>
+          <a:xfrm>
+            <a:off x="180000" y="936000"/>
+            <a:ext cx="2294640" cy="540000"/>
+          </a:xfrm>
+          <a:prstGeom prst="rect">
+            <a:avLst/>
+          </a:prstGeom>
+          <a:solidFill>
+            <a:srgbClr val="E85D5D"/>
+          </a:solidFill>
+          <a:ln>
+            <a:noFill/>
+          </a:ln>
+        </p:spPr>
+        <p:style>
+          <a:lnRef idx="1">
+            <a:schemeClr val="accent1"/>
+          </a:lnRef>
+          <a:fillRef idx="3">
+            <a:schemeClr val="accent1"/>
+          </a:fillRef>
+          <a:effectRef idx="2">
+            <a:schemeClr val="accent1"/>
+          </a:effectRef>
+          <a:fontRef idx="minor">
+            <a:schemeClr val="lt1"/>
+          </a:fontRef>
+        </p:style>
+        <p:txBody>
+          <a:bodyPr rtlCol="0" anchor="ctr"/>
+          <a:lstStyle/>
+          <a:p>
+            <a:pPr algn="ctr"/>
+          </a:p>
+        </p:txBody>
+      </p:sp>
+      <p:sp>
+        <p:nvSpPr>
+          <p:cNvPr id="6" name="TextBox 5"/>
+          <p:cNvSpPr txBox="1"/>
+          <p:nvPr/>
+        </p:nvSpPr>
+        <p:spPr>
+          <a:xfrm>
+            <a:off x="216000" y="972000"/>
+            <a:ext cx="2258640" cy="468000"/>
+          </a:xfrm>
+          <a:prstGeom prst="rect">
+            <a:avLst/>
+          </a:prstGeom>
+          <a:noFill/>
+        </p:spPr>
+        <p:txBody>
+          <a:bodyPr wrap="none">
+            <a:spAutoFit/>
+          </a:bodyPr>
+          <a:lstStyle/>
+          <a:p>
+            <a:pPr algn="ctr"/>
+            <a:r>
+              <a:rPr sz="1300" b="1">
+                <a:solidFill>
+                  <a:srgbClr val="FFFFFF"/>
+                </a:solidFill>
+                <a:latin typeface="IPAゴシック"/>
+              </a:rPr>
+              <a:t>■ 旧帝国大学・最難関</a:t>
+            </a:r>
+          </a:p>
+        </p:txBody>
+      </p:sp>
+      <p:sp>
+        <p:nvSpPr>
+          <p:cNvPr id="7" name="Rectangle 6"/>
+          <p:cNvSpPr/>
+          <p:nvPr/>
+        </p:nvSpPr>
+        <p:spPr>
+          <a:xfrm>
+            <a:off x="216000" y="1548000"/>
+            <a:ext cx="2258640" cy="540000"/>
+          </a:xfrm>
+          <a:prstGeom prst="rect">
+            <a:avLst/>
+          </a:prstGeom>
+          <a:solidFill>
+            <a:srgbClr val="FFFFFF"/>
+          </a:solidFill>
+          <a:ln w="12700">
+            <a:solidFill>
+              <a:srgbClr val="E85D5D"/>
+            </a:solidFill>
+          </a:ln>
+        </p:spPr>
+        <p:style>
+          <a:lnRef idx="1">
+            <a:schemeClr val="accent1"/>
+          </a:lnRef>
+          <a:fillRef idx="3">
+            <a:schemeClr val="accent1"/>
+          </a:fillRef>
+          <a:effectRef idx="2">
+            <a:schemeClr val="accent1"/>
+          </a:effectRef>
+          <a:fontRef idx="minor">
+            <a:schemeClr val="lt1"/>
+          </a:fontRef>
+        </p:style>
+        <p:txBody>
+          <a:bodyPr rtlCol="0" anchor="ctr"/>
+          <a:lstStyle/>
+          <a:p>
+            <a:pPr algn="ctr"/>
+          </a:p>
+        </p:txBody>
+      </p:sp>
+      <p:sp>
+        <p:nvSpPr>
+          <p:cNvPr id="8" name="TextBox 7"/>
+          <p:cNvSpPr txBox="1"/>
+          <p:nvPr/>
+        </p:nvSpPr>
+        <p:spPr>
+          <a:xfrm>
+            <a:off x="252000" y="1584000"/>
+            <a:ext cx="2186640" cy="468000"/>
+          </a:xfrm>
+          <a:prstGeom prst="rect">
+            <a:avLst/>
+          </a:prstGeom>
+          <a:noFill/>
+        </p:spPr>
+        <p:txBody>
+          <a:bodyPr wrap="none">
+            <a:spAutoFit/>
+          </a:bodyPr>
+          <a:lstStyle/>
+          <a:p>
+            <a:pPr algn="ctr"/>
+            <a:r>
+              <a:rPr sz="1300" b="1">
+                <a:solidFill>
+                  <a:srgbClr val="1F3564"/>
+                </a:solidFill>
+                <a:latin typeface="IPAゴシック"/>
+              </a:rPr>
+              <a:t>東京大学</a:t>
+            </a:r>
+          </a:p>
+        </p:txBody>
+      </p:sp>
+      <p:sp>
+        <p:nvSpPr>
+          <p:cNvPr id="9" name="Rectangle 8"/>
+          <p:cNvSpPr/>
+          <p:nvPr/>
+        </p:nvSpPr>
+        <p:spPr>
+          <a:xfrm>
+            <a:off x="216000" y="2142000"/>
+            <a:ext cx="2258640" cy="540000"/>
+          </a:xfrm>
+          <a:prstGeom prst="rect">
+            <a:avLst/>
+          </a:prstGeom>
+          <a:solidFill>
+            <a:srgbClr val="FFFFFF"/>
+          </a:solidFill>
+          <a:ln w="12700">
+            <a:solidFill>
+              <a:srgbClr val="E85D5D"/>
+            </a:solidFill>
+          </a:ln>
+        </p:spPr>
+        <p:style>
+          <a:lnRef idx="1">
+            <a:schemeClr val="accent1"/>
+          </a:lnRef>
+          <a:fillRef idx="3">
+            <a:schemeClr val="accent1"/>
+          </a:fillRef>
+          <a:effectRef idx="2">
+            <a:schemeClr val="accent1"/>
+          </a:effectRef>
+          <a:fontRef idx="minor">
+            <a:schemeClr val="lt1"/>
+          </a:fontRef>
+        </p:style>
+        <p:txBody>
+          <a:bodyPr rtlCol="0" anchor="ctr"/>
+          <a:lstStyle/>
+          <a:p>
+            <a:pPr algn="ctr"/>
+          </a:p>
+        </p:txBody>
+      </p:sp>
+      <p:sp>
+        <p:nvSpPr>
+          <p:cNvPr id="10" name="TextBox 9"/>
+          <p:cNvSpPr txBox="1"/>
+          <p:nvPr/>
+        </p:nvSpPr>
+        <p:spPr>
+          <a:xfrm>
+            <a:off x="252000" y="2178000"/>
+            <a:ext cx="2186640" cy="468000"/>
+          </a:xfrm>
+          <a:prstGeom prst="rect">
+            <a:avLst/>
+          </a:prstGeom>
+          <a:noFill/>
+        </p:spPr>
+        <p:txBody>
+          <a:bodyPr wrap="none">
+            <a:spAutoFit/>
+          </a:bodyPr>
+          <a:lstStyle/>
+          <a:p>
+            <a:pPr algn="ctr"/>
+            <a:r>
+              <a:rPr sz="1300" b="1">
+                <a:solidFill>
+                  <a:srgbClr val="1F3564"/>
+                </a:solidFill>
+                <a:latin typeface="IPAゴシック"/>
+              </a:rPr>
+              <a:t>京都大学</a:t>
+            </a:r>
+          </a:p>
+        </p:txBody>
+      </p:sp>
+      <p:sp>
+        <p:nvSpPr>
+          <p:cNvPr id="11" name="Rectangle 10"/>
+          <p:cNvSpPr/>
+          <p:nvPr/>
+        </p:nvSpPr>
+        <p:spPr>
+          <a:xfrm>
+            <a:off x="216000" y="2736000"/>
+            <a:ext cx="2258640" cy="540000"/>
+          </a:xfrm>
+          <a:prstGeom prst="rect">
+            <a:avLst/>
+          </a:prstGeom>
+          <a:solidFill>
+            <a:srgbClr val="FFFFFF"/>
+          </a:solidFill>
+          <a:ln w="12700">
+            <a:solidFill>
+              <a:srgbClr val="E85D5D"/>
+            </a:solidFill>
+          </a:ln>
+        </p:spPr>
+        <p:style>
+          <a:lnRef idx="1">
+            <a:schemeClr val="accent1"/>
+          </a:lnRef>
+          <a:fillRef idx="3">
+            <a:schemeClr val="accent1"/>
+          </a:fillRef>
+          <a:effectRef idx="2">
+            <a:schemeClr val="accent1"/>
+          </a:effectRef>
+          <a:fontRef idx="minor">
+            <a:schemeClr val="lt1"/>
+          </a:fontRef>
+        </p:style>
+        <p:txBody>
+          <a:bodyPr rtlCol="0" anchor="ctr"/>
+          <a:lstStyle/>
+          <a:p>
+            <a:pPr algn="ctr"/>
+          </a:p>
+        </p:txBody>
+      </p:sp>
+      <p:sp>
+        <p:nvSpPr>
+          <p:cNvPr id="12" name="TextBox 11"/>
+          <p:cNvSpPr txBox="1"/>
+          <p:nvPr/>
+        </p:nvSpPr>
+        <p:spPr>
+          <a:xfrm>
+            <a:off x="252000" y="2772000"/>
+            <a:ext cx="2186640" cy="468000"/>
+          </a:xfrm>
+          <a:prstGeom prst="rect">
+            <a:avLst/>
+          </a:prstGeom>
+          <a:noFill/>
+        </p:spPr>
+        <p:txBody>
+          <a:bodyPr wrap="none">
+            <a:spAutoFit/>
+          </a:bodyPr>
+          <a:lstStyle/>
+          <a:p>
+            <a:pPr algn="ctr"/>
+            <a:r>
+              <a:rPr sz="1300" b="1">
+                <a:solidFill>
+                  <a:srgbClr val="1F3564"/>
+                </a:solidFill>
+                <a:latin typeface="IPAゴシック"/>
+              </a:rPr>
+              <a:t>大阪大学</a:t>
+            </a:r>
+          </a:p>
+        </p:txBody>
+      </p:sp>
+      <p:sp>
+        <p:nvSpPr>
+          <p:cNvPr id="13" name="Rectangle 12"/>
+          <p:cNvSpPr/>
+          <p:nvPr/>
+        </p:nvSpPr>
+        <p:spPr>
+          <a:xfrm>
+            <a:off x="216000" y="3330000"/>
+            <a:ext cx="2258640" cy="540000"/>
+          </a:xfrm>
+          <a:prstGeom prst="rect">
+            <a:avLst/>
+          </a:prstGeom>
+          <a:solidFill>
+            <a:srgbClr val="FFFFFF"/>
+          </a:solidFill>
+          <a:ln w="12700">
+            <a:solidFill>
+              <a:srgbClr val="E85D5D"/>
+            </a:solidFill>
+          </a:ln>
+        </p:spPr>
+        <p:style>
+          <a:lnRef idx="1">
+            <a:schemeClr val="accent1"/>
+          </a:lnRef>
+          <a:fillRef idx="3">
+            <a:schemeClr val="accent1"/>
+          </a:fillRef>
+          <a:effectRef idx="2">
+            <a:schemeClr val="accent1"/>
+          </a:effectRef>
+          <a:fontRef idx="minor">
+            <a:schemeClr val="lt1"/>
+          </a:fontRef>
+        </p:style>
+        <p:txBody>
+          <a:bodyPr rtlCol="0" anchor="ctr"/>
+          <a:lstStyle/>
+          <a:p>
+            <a:pPr algn="ctr"/>
+          </a:p>
+        </p:txBody>
+      </p:sp>
+      <p:sp>
+        <p:nvSpPr>
+          <p:cNvPr id="14" name="TextBox 13"/>
+          <p:cNvSpPr txBox="1"/>
+          <p:nvPr/>
+        </p:nvSpPr>
+        <p:spPr>
+          <a:xfrm>
+            <a:off x="252000" y="3366000"/>
+            <a:ext cx="2186640" cy="468000"/>
+          </a:xfrm>
+          <a:prstGeom prst="rect">
+            <a:avLst/>
+          </a:prstGeom>
+          <a:noFill/>
+        </p:spPr>
+        <p:txBody>
+          <a:bodyPr wrap="none">
+            <a:spAutoFit/>
+          </a:bodyPr>
+          <a:lstStyle/>
+          <a:p>
+            <a:pPr algn="ctr"/>
+            <a:r>
+              <a:rPr sz="1300" b="1">
+                <a:solidFill>
+                  <a:srgbClr val="1F3564"/>
+                </a:solidFill>
+                <a:latin typeface="IPAゴシック"/>
+              </a:rPr>
+              <a:t>東北大学</a:t>
+            </a:r>
+          </a:p>
+        </p:txBody>
+      </p:sp>
+      <p:sp>
+        <p:nvSpPr>
+          <p:cNvPr id="15" name="Rectangle 14"/>
+          <p:cNvSpPr/>
+          <p:nvPr/>
+        </p:nvSpPr>
+        <p:spPr>
+          <a:xfrm>
+            <a:off x="216000" y="3924000"/>
+            <a:ext cx="2258640" cy="540000"/>
+          </a:xfrm>
+          <a:prstGeom prst="rect">
+            <a:avLst/>
+          </a:prstGeom>
+          <a:solidFill>
+            <a:srgbClr val="FFFFFF"/>
+          </a:solidFill>
+          <a:ln w="12700">
+            <a:solidFill>
+              <a:srgbClr val="E85D5D"/>
+            </a:solidFill>
+          </a:ln>
+        </p:spPr>
+        <p:style>
+          <a:lnRef idx="1">
+            <a:schemeClr val="accent1"/>
+          </a:lnRef>
+          <a:fillRef idx="3">
+            <a:schemeClr val="accent1"/>
+          </a:fillRef>
+          <a:effectRef idx="2">
+            <a:schemeClr val="accent1"/>
+          </a:effectRef>
+          <a:fontRef idx="minor">
+            <a:schemeClr val="lt1"/>
+          </a:fontRef>
+        </p:style>
+        <p:txBody>
+          <a:bodyPr rtlCol="0" anchor="ctr"/>
+          <a:lstStyle/>
+          <a:p>
+            <a:pPr algn="ctr"/>
+          </a:p>
+        </p:txBody>
+      </p:sp>
+      <p:sp>
+        <p:nvSpPr>
+          <p:cNvPr id="16" name="TextBox 15"/>
+          <p:cNvSpPr txBox="1"/>
+          <p:nvPr/>
+        </p:nvSpPr>
+        <p:spPr>
+          <a:xfrm>
+            <a:off x="252000" y="3960000"/>
+            <a:ext cx="2186640" cy="468000"/>
+          </a:xfrm>
+          <a:prstGeom prst="rect">
+            <a:avLst/>
+          </a:prstGeom>
+          <a:noFill/>
+        </p:spPr>
+        <p:txBody>
+          <a:bodyPr wrap="none">
+            <a:spAutoFit/>
+          </a:bodyPr>
+          <a:lstStyle/>
+          <a:p>
+            <a:pPr algn="ctr"/>
+            <a:r>
+              <a:rPr sz="1300" b="1">
+                <a:solidFill>
+                  <a:srgbClr val="1F3564"/>
+                </a:solidFill>
+                <a:latin typeface="IPAゴシック"/>
+              </a:rPr>
+              <a:t>名古屋大学</a:t>
+            </a:r>
+          </a:p>
+        </p:txBody>
+      </p:sp>
+      <p:sp>
+        <p:nvSpPr>
+          <p:cNvPr id="17" name="Rectangle 16"/>
+          <p:cNvSpPr/>
+          <p:nvPr/>
+        </p:nvSpPr>
+        <p:spPr>
+          <a:xfrm>
+            <a:off x="216000" y="4518000"/>
+            <a:ext cx="2258640" cy="540000"/>
+          </a:xfrm>
+          <a:prstGeom prst="rect">
+            <a:avLst/>
+          </a:prstGeom>
+          <a:solidFill>
+            <a:srgbClr val="FFFFFF"/>
+          </a:solidFill>
+          <a:ln w="12700">
+            <a:solidFill>
+              <a:srgbClr val="E85D5D"/>
+            </a:solidFill>
+          </a:ln>
+        </p:spPr>
+        <p:style>
+          <a:lnRef idx="1">
+            <a:schemeClr val="accent1"/>
+          </a:lnRef>
+          <a:fillRef idx="3">
+            <a:schemeClr val="accent1"/>
+          </a:fillRef>
+          <a:effectRef idx="2">
+            <a:schemeClr val="accent1"/>
+          </a:effectRef>
+          <a:fontRef idx="minor">
+            <a:schemeClr val="lt1"/>
+          </a:fontRef>
+        </p:style>
+        <p:txBody>
+          <a:bodyPr rtlCol="0" anchor="ctr"/>
+          <a:lstStyle/>
+          <a:p>
+            <a:pPr algn="ctr"/>
+          </a:p>
+        </p:txBody>
+      </p:sp>
+      <p:sp>
+        <p:nvSpPr>
+          <p:cNvPr id="18" name="TextBox 17"/>
+          <p:cNvSpPr txBox="1"/>
+          <p:nvPr/>
+        </p:nvSpPr>
+        <p:spPr>
+          <a:xfrm>
+            <a:off x="252000" y="4554000"/>
+            <a:ext cx="2186640" cy="468000"/>
+          </a:xfrm>
+          <a:prstGeom prst="rect">
+            <a:avLst/>
+          </a:prstGeom>
+          <a:noFill/>
+        </p:spPr>
+        <p:txBody>
+          <a:bodyPr wrap="none">
+            <a:spAutoFit/>
+          </a:bodyPr>
+          <a:lstStyle/>
+          <a:p>
+            <a:pPr algn="ctr"/>
+            <a:r>
+              <a:rPr sz="1300" b="1">
+                <a:solidFill>
+                  <a:srgbClr val="1F3564"/>
+                </a:solidFill>
+                <a:latin typeface="IPAゴシック"/>
+              </a:rPr>
+              <a:t>九州大学</a:t>
+            </a:r>
+          </a:p>
+        </p:txBody>
+      </p:sp>
+      <p:sp>
+        <p:nvSpPr>
+          <p:cNvPr id="19" name="Rectangle 18"/>
+          <p:cNvSpPr/>
+          <p:nvPr/>
+        </p:nvSpPr>
+        <p:spPr>
+          <a:xfrm>
+            <a:off x="216000" y="5112000"/>
+            <a:ext cx="2258640" cy="540000"/>
+          </a:xfrm>
+          <a:prstGeom prst="rect">
+            <a:avLst/>
+          </a:prstGeom>
+          <a:solidFill>
+            <a:srgbClr val="FFFFFF"/>
+          </a:solidFill>
+          <a:ln w="12700">
+            <a:solidFill>
+              <a:srgbClr val="E85D5D"/>
+            </a:solidFill>
+          </a:ln>
+        </p:spPr>
+        <p:style>
+          <a:lnRef idx="1">
+            <a:schemeClr val="accent1"/>
+          </a:lnRef>
+          <a:fillRef idx="3">
+            <a:schemeClr val="accent1"/>
+          </a:fillRef>
+          <a:effectRef idx="2">
+            <a:schemeClr val="accent1"/>
+          </a:effectRef>
+          <a:fontRef idx="minor">
+            <a:schemeClr val="lt1"/>
+          </a:fontRef>
+        </p:style>
+        <p:txBody>
+          <a:bodyPr rtlCol="0" anchor="ctr"/>
+          <a:lstStyle/>
+          <a:p>
+            <a:pPr algn="ctr"/>
+          </a:p>
+        </p:txBody>
+      </p:sp>
+      <p:sp>
+        <p:nvSpPr>
+          <p:cNvPr id="20" name="TextBox 19"/>
+          <p:cNvSpPr txBox="1"/>
+          <p:nvPr/>
+        </p:nvSpPr>
+        <p:spPr>
+          <a:xfrm>
+            <a:off x="252000" y="5148000"/>
+            <a:ext cx="2186640" cy="468000"/>
+          </a:xfrm>
+          <a:prstGeom prst="rect">
+            <a:avLst/>
+          </a:prstGeom>
+          <a:noFill/>
+        </p:spPr>
+        <p:txBody>
+          <a:bodyPr wrap="none">
+            <a:spAutoFit/>
+          </a:bodyPr>
+          <a:lstStyle/>
+          <a:p>
+            <a:pPr algn="ctr"/>
+            <a:r>
+              <a:rPr sz="1300" b="1">
+                <a:solidFill>
+                  <a:srgbClr val="1F3564"/>
+                </a:solidFill>
+                <a:latin typeface="IPAゴシック"/>
+              </a:rPr>
+              <a:t>北海道大学</a:t>
+            </a:r>
+          </a:p>
+        </p:txBody>
+      </p:sp>
+      <p:sp>
+        <p:nvSpPr>
+          <p:cNvPr id="21" name="Rectangle 20"/>
+          <p:cNvSpPr/>
+          <p:nvPr/>
+        </p:nvSpPr>
+        <p:spPr>
+          <a:xfrm>
+            <a:off x="2546640" y="936000"/>
+            <a:ext cx="2294640" cy="540000"/>
+          </a:xfrm>
+          <a:prstGeom prst="rect">
+            <a:avLst/>
+          </a:prstGeom>
+          <a:solidFill>
+            <a:srgbClr val="9B59B6"/>
+          </a:solidFill>
+          <a:ln>
+            <a:noFill/>
+          </a:ln>
+        </p:spPr>
+        <p:style>
+          <a:lnRef idx="1">
+            <a:schemeClr val="accent1"/>
+          </a:lnRef>
+          <a:fillRef idx="3">
+            <a:schemeClr val="accent1"/>
+          </a:fillRef>
+          <a:effectRef idx="2">
+            <a:schemeClr val="accent1"/>
+          </a:effectRef>
+          <a:fontRef idx="minor">
+            <a:schemeClr val="lt1"/>
+          </a:fontRef>
+        </p:style>
+        <p:txBody>
+          <a:bodyPr rtlCol="0" anchor="ctr"/>
+          <a:lstStyle/>
+          <a:p>
+            <a:pPr algn="ctr"/>
+          </a:p>
+        </p:txBody>
+      </p:sp>
+      <p:sp>
+        <p:nvSpPr>
+          <p:cNvPr id="22" name="TextBox 21"/>
+          <p:cNvSpPr txBox="1"/>
+          <p:nvPr/>
+        </p:nvSpPr>
+        <p:spPr>
+          <a:xfrm>
+            <a:off x="2582640" y="972000"/>
+            <a:ext cx="2258640" cy="468000"/>
+          </a:xfrm>
+          <a:prstGeom prst="rect">
+            <a:avLst/>
+          </a:prstGeom>
+          <a:noFill/>
+        </p:spPr>
+        <p:txBody>
+          <a:bodyPr wrap="none">
+            <a:spAutoFit/>
+          </a:bodyPr>
+          <a:lstStyle/>
+          <a:p>
+            <a:pPr algn="ctr"/>
+            <a:r>
+              <a:rPr sz="1300" b="1">
+                <a:solidFill>
+                  <a:srgbClr val="FFFFFF"/>
+                </a:solidFill>
+                <a:latin typeface="IPAゴシック"/>
+              </a:rPr>
+              <a:t>■ 私立最難関（早慶）</a:t>
+            </a:r>
+          </a:p>
+        </p:txBody>
+      </p:sp>
+      <p:sp>
+        <p:nvSpPr>
+          <p:cNvPr id="23" name="Rectangle 22"/>
+          <p:cNvSpPr/>
+          <p:nvPr/>
+        </p:nvSpPr>
+        <p:spPr>
+          <a:xfrm>
+            <a:off x="2582640" y="1548000"/>
+            <a:ext cx="2258640" cy="540000"/>
+          </a:xfrm>
+          <a:prstGeom prst="rect">
+            <a:avLst/>
+          </a:prstGeom>
+          <a:solidFill>
+            <a:srgbClr val="FFFFFF"/>
+          </a:solidFill>
+          <a:ln w="12700">
+            <a:solidFill>
+              <a:srgbClr val="9B59B6"/>
+            </a:solidFill>
+          </a:ln>
+        </p:spPr>
+        <p:style>
+          <a:lnRef idx="1">
+            <a:schemeClr val="accent1"/>
+          </a:lnRef>
+          <a:fillRef idx="3">
+            <a:schemeClr val="accent1"/>
+          </a:fillRef>
+          <a:effectRef idx="2">
+            <a:schemeClr val="accent1"/>
+          </a:effectRef>
+          <a:fontRef idx="minor">
+            <a:schemeClr val="lt1"/>
+          </a:fontRef>
+        </p:style>
+        <p:txBody>
+          <a:bodyPr rtlCol="0" anchor="ctr"/>
+          <a:lstStyle/>
+          <a:p>
+            <a:pPr algn="ctr"/>
+          </a:p>
+        </p:txBody>
+      </p:sp>
+      <p:sp>
+        <p:nvSpPr>
+          <p:cNvPr id="24" name="TextBox 23"/>
+          <p:cNvSpPr txBox="1"/>
+          <p:nvPr/>
+        </p:nvSpPr>
+        <p:spPr>
+          <a:xfrm>
+            <a:off x="2618640" y="1584000"/>
+            <a:ext cx="2186640" cy="468000"/>
+          </a:xfrm>
+          <a:prstGeom prst="rect">
+            <a:avLst/>
+          </a:prstGeom>
+          <a:noFill/>
+        </p:spPr>
+        <p:txBody>
+          <a:bodyPr wrap="none">
+            <a:spAutoFit/>
+          </a:bodyPr>
+          <a:lstStyle/>
+          <a:p>
+            <a:pPr algn="ctr"/>
+            <a:r>
+              <a:rPr sz="1300" b="1">
+                <a:solidFill>
+                  <a:srgbClr val="1F3564"/>
+                </a:solidFill>
+                <a:latin typeface="IPAゴシック"/>
+              </a:rPr>
+              <a:t>慶應義塾大学</a:t>
+            </a:r>
+          </a:p>
+        </p:txBody>
+      </p:sp>
+      <p:sp>
+        <p:nvSpPr>
+          <p:cNvPr id="25" name="Rectangle 24"/>
+          <p:cNvSpPr/>
+          <p:nvPr/>
+        </p:nvSpPr>
+        <p:spPr>
+          <a:xfrm>
+            <a:off x="2582640" y="2142000"/>
+            <a:ext cx="2258640" cy="540000"/>
+          </a:xfrm>
+          <a:prstGeom prst="rect">
+            <a:avLst/>
+          </a:prstGeom>
+          <a:solidFill>
+            <a:srgbClr val="FFFFFF"/>
+          </a:solidFill>
+          <a:ln w="12700">
+            <a:solidFill>
+              <a:srgbClr val="9B59B6"/>
+            </a:solidFill>
+          </a:ln>
+        </p:spPr>
+        <p:style>
+          <a:lnRef idx="1">
+            <a:schemeClr val="accent1"/>
+          </a:lnRef>
+          <a:fillRef idx="3">
+            <a:schemeClr val="accent1"/>
+          </a:fillRef>
+          <a:effectRef idx="2">
+            <a:schemeClr val="accent1"/>
+          </a:effectRef>
+          <a:fontRef idx="minor">
+            <a:schemeClr val="lt1"/>
+          </a:fontRef>
+        </p:style>
+        <p:txBody>
+          <a:bodyPr rtlCol="0" anchor="ctr"/>
+          <a:lstStyle/>
+          <a:p>
+            <a:pPr algn="ctr"/>
+          </a:p>
+        </p:txBody>
+      </p:sp>
+      <p:sp>
+        <p:nvSpPr>
+          <p:cNvPr id="26" name="TextBox 25"/>
+          <p:cNvSpPr txBox="1"/>
+          <p:nvPr/>
+        </p:nvSpPr>
+        <p:spPr>
+          <a:xfrm>
+            <a:off x="2618640" y="2178000"/>
+            <a:ext cx="2186640" cy="468000"/>
+          </a:xfrm>
+          <a:prstGeom prst="rect">
+            <a:avLst/>
+          </a:prstGeom>
+          <a:noFill/>
+        </p:spPr>
+        <p:txBody>
+          <a:bodyPr wrap="none">
+            <a:spAutoFit/>
+          </a:bodyPr>
+          <a:lstStyle/>
+          <a:p>
+            <a:pPr algn="ctr"/>
+            <a:r>
+              <a:rPr sz="1300" b="1">
+                <a:solidFill>
+                  <a:srgbClr val="1F3564"/>
+                </a:solidFill>
+                <a:latin typeface="IPAゴシック"/>
+              </a:rPr>
+              <a:t>早稲田大学</a:t>
+            </a:r>
+          </a:p>
+        </p:txBody>
+      </p:sp>
+      <p:sp>
+        <p:nvSpPr>
+          <p:cNvPr id="27" name="Rectangle 26"/>
+          <p:cNvSpPr/>
+          <p:nvPr/>
+        </p:nvSpPr>
+        <p:spPr>
+          <a:xfrm>
+            <a:off x="4913280" y="936000"/>
+            <a:ext cx="2294640" cy="540000"/>
+          </a:xfrm>
+          <a:prstGeom prst="rect">
+            <a:avLst/>
+          </a:prstGeom>
+          <a:solidFill>
+            <a:srgbClr val="F5A623"/>
+          </a:solidFill>
+          <a:ln>
+            <a:noFill/>
+          </a:ln>
+        </p:spPr>
+        <p:style>
+          <a:lnRef idx="1">
+            <a:schemeClr val="accent1"/>
+          </a:lnRef>
+          <a:fillRef idx="3">
+            <a:schemeClr val="accent1"/>
+          </a:fillRef>
+          <a:effectRef idx="2">
+            <a:schemeClr val="accent1"/>
+          </a:effectRef>
+          <a:fontRef idx="minor">
+            <a:schemeClr val="lt1"/>
+          </a:fontRef>
+        </p:style>
+        <p:txBody>
+          <a:bodyPr rtlCol="0" anchor="ctr"/>
+          <a:lstStyle/>
+          <a:p>
+            <a:pPr algn="ctr"/>
+          </a:p>
+        </p:txBody>
+      </p:sp>
+      <p:sp>
+        <p:nvSpPr>
+          <p:cNvPr id="28" name="TextBox 27"/>
+          <p:cNvSpPr txBox="1"/>
+          <p:nvPr/>
+        </p:nvSpPr>
+        <p:spPr>
+          <a:xfrm>
+            <a:off x="4949280" y="972000"/>
+            <a:ext cx="2258640" cy="468000"/>
+          </a:xfrm>
+          <a:prstGeom prst="rect">
+            <a:avLst/>
+          </a:prstGeom>
+          <a:noFill/>
+        </p:spPr>
+        <p:txBody>
+          <a:bodyPr wrap="none">
+            <a:spAutoFit/>
+          </a:bodyPr>
+          <a:lstStyle/>
+          <a:p>
+            <a:pPr algn="ctr"/>
+            <a:r>
+              <a:rPr sz="1300" b="1">
+                <a:solidFill>
+                  <a:srgbClr val="FFFFFF"/>
+                </a:solidFill>
+                <a:latin typeface="IPAゴシック"/>
+              </a:rPr>
+              <a:t>■ 準難関私立</a:t>
+            </a:r>
+          </a:p>
+        </p:txBody>
+      </p:sp>
+      <p:sp>
+        <p:nvSpPr>
+          <p:cNvPr id="29" name="Rectangle 28"/>
+          <p:cNvSpPr/>
+          <p:nvPr/>
+        </p:nvSpPr>
+        <p:spPr>
+          <a:xfrm>
+            <a:off x="4949280" y="1548000"/>
+            <a:ext cx="2258640" cy="540000"/>
+          </a:xfrm>
+          <a:prstGeom prst="rect">
+            <a:avLst/>
+          </a:prstGeom>
+          <a:solidFill>
+            <a:srgbClr val="FFFFFF"/>
+          </a:solidFill>
+          <a:ln w="12700">
+            <a:solidFill>
+              <a:srgbClr val="F5A623"/>
+            </a:solidFill>
+          </a:ln>
+        </p:spPr>
+        <p:style>
+          <a:lnRef idx="1">
+            <a:schemeClr val="accent1"/>
+          </a:lnRef>
+          <a:fillRef idx="3">
+            <a:schemeClr val="accent1"/>
+          </a:fillRef>
+          <a:effectRef idx="2">
+            <a:schemeClr val="accent1"/>
+          </a:effectRef>
+          <a:fontRef idx="minor">
+            <a:schemeClr val="lt1"/>
+          </a:fontRef>
+        </p:style>
+        <p:txBody>
+          <a:bodyPr rtlCol="0" anchor="ctr"/>
+          <a:lstStyle/>
+          <a:p>
+            <a:pPr algn="ctr"/>
+          </a:p>
+        </p:txBody>
+      </p:sp>
+      <p:sp>
+        <p:nvSpPr>
+          <p:cNvPr id="30" name="TextBox 29"/>
+          <p:cNvSpPr txBox="1"/>
+          <p:nvPr/>
+        </p:nvSpPr>
+        <p:spPr>
+          <a:xfrm>
+            <a:off x="4985280" y="1584000"/>
+            <a:ext cx="2186640" cy="468000"/>
+          </a:xfrm>
+          <a:prstGeom prst="rect">
+            <a:avLst/>
+          </a:prstGeom>
+          <a:noFill/>
+        </p:spPr>
+        <p:txBody>
+          <a:bodyPr wrap="none">
+            <a:spAutoFit/>
+          </a:bodyPr>
+          <a:lstStyle/>
+          <a:p>
+            <a:pPr algn="ctr"/>
+            <a:r>
+              <a:rPr sz="1300" b="1">
+                <a:solidFill>
+                  <a:srgbClr val="1F3564"/>
+                </a:solidFill>
+                <a:latin typeface="IPAゴシック"/>
+              </a:rPr>
+              <a:t>上智大学</a:t>
+            </a:r>
+          </a:p>
+        </p:txBody>
+      </p:sp>
+      <p:sp>
+        <p:nvSpPr>
+          <p:cNvPr id="31" name="Rectangle 30"/>
+          <p:cNvSpPr/>
+          <p:nvPr/>
+        </p:nvSpPr>
+        <p:spPr>
+          <a:xfrm>
+            <a:off x="4949280" y="2142000"/>
+            <a:ext cx="2258640" cy="540000"/>
+          </a:xfrm>
+          <a:prstGeom prst="rect">
+            <a:avLst/>
+          </a:prstGeom>
+          <a:solidFill>
+            <a:srgbClr val="FFFFFF"/>
+          </a:solidFill>
+          <a:ln w="12700">
+            <a:solidFill>
+              <a:srgbClr val="F5A623"/>
+            </a:solidFill>
+          </a:ln>
+        </p:spPr>
+        <p:style>
+          <a:lnRef idx="1">
+            <a:schemeClr val="accent1"/>
+          </a:lnRef>
+          <a:fillRef idx="3">
+            <a:schemeClr val="accent1"/>
+          </a:fillRef>
+          <a:effectRef idx="2">
+            <a:schemeClr val="accent1"/>
+          </a:effectRef>
+          <a:fontRef idx="minor">
+            <a:schemeClr val="lt1"/>
+          </a:fontRef>
+        </p:style>
+        <p:txBody>
+          <a:bodyPr rtlCol="0" anchor="ctr"/>
+          <a:lstStyle/>
+          <a:p>
+            <a:pPr algn="ctr"/>
+          </a:p>
+        </p:txBody>
+      </p:sp>
+      <p:sp>
+        <p:nvSpPr>
+          <p:cNvPr id="32" name="TextBox 31"/>
+          <p:cNvSpPr txBox="1"/>
+          <p:nvPr/>
+        </p:nvSpPr>
+        <p:spPr>
+          <a:xfrm>
+            <a:off x="4985280" y="2178000"/>
+            <a:ext cx="2186640" cy="468000"/>
+          </a:xfrm>
+          <a:prstGeom prst="rect">
+            <a:avLst/>
+          </a:prstGeom>
+          <a:noFill/>
+        </p:spPr>
+        <p:txBody>
+          <a:bodyPr wrap="none">
+            <a:spAutoFit/>
+          </a:bodyPr>
+          <a:lstStyle/>
+          <a:p>
+            <a:pPr algn="ctr"/>
+            <a:r>
+              <a:rPr sz="1300" b="1">
+                <a:solidFill>
+                  <a:srgbClr val="1F3564"/>
+                </a:solidFill>
+                <a:latin typeface="IPAゴシック"/>
+              </a:rPr>
+              <a:t>東京理科大学</a:t>
+            </a:r>
+          </a:p>
+        </p:txBody>
+      </p:sp>
+      <p:sp>
+        <p:nvSpPr>
+          <p:cNvPr id="33" name="Rectangle 32"/>
+          <p:cNvSpPr/>
+          <p:nvPr/>
+        </p:nvSpPr>
+        <p:spPr>
+          <a:xfrm>
+            <a:off x="4949280" y="2736000"/>
+            <a:ext cx="2258640" cy="540000"/>
+          </a:xfrm>
+          <a:prstGeom prst="rect">
+            <a:avLst/>
+          </a:prstGeom>
+          <a:solidFill>
+            <a:srgbClr val="FFFFFF"/>
+          </a:solidFill>
+          <a:ln w="12700">
+            <a:solidFill>
+              <a:srgbClr val="F5A623"/>
+            </a:solidFill>
+          </a:ln>
+        </p:spPr>
+        <p:style>
+          <a:lnRef idx="1">
+            <a:schemeClr val="accent1"/>
+          </a:lnRef>
+          <a:fillRef idx="3">
+            <a:schemeClr val="accent1"/>
+          </a:fillRef>
+          <a:effectRef idx="2">
+            <a:schemeClr val="accent1"/>
+          </a:effectRef>
+          <a:fontRef idx="minor">
+            <a:schemeClr val="lt1"/>
+          </a:fontRef>
+        </p:style>
+        <p:txBody>
+          <a:bodyPr rtlCol="0" anchor="ctr"/>
+          <a:lstStyle/>
+          <a:p>
+            <a:pPr algn="ctr"/>
+          </a:p>
+        </p:txBody>
+      </p:sp>
+      <p:sp>
+        <p:nvSpPr>
+          <p:cNvPr id="34" name="TextBox 33"/>
+          <p:cNvSpPr txBox="1"/>
+          <p:nvPr/>
+        </p:nvSpPr>
+        <p:spPr>
+          <a:xfrm>
+            <a:off x="4985280" y="2772000"/>
+            <a:ext cx="2186640" cy="468000"/>
+          </a:xfrm>
+          <a:prstGeom prst="rect">
+            <a:avLst/>
+          </a:prstGeom>
+          <a:noFill/>
+        </p:spPr>
+        <p:txBody>
+          <a:bodyPr wrap="none">
+            <a:spAutoFit/>
+          </a:bodyPr>
+          <a:lstStyle/>
+          <a:p>
+            <a:pPr algn="ctr"/>
+            <a:r>
+              <a:rPr sz="1300" b="1">
+                <a:solidFill>
+                  <a:srgbClr val="1F3564"/>
+                </a:solidFill>
+                <a:latin typeface="IPAゴシック"/>
+              </a:rPr>
+              <a:t>国際基督教大学</a:t>
+            </a:r>
+          </a:p>
+        </p:txBody>
+      </p:sp>
+      <p:sp>
+        <p:nvSpPr>
+          <p:cNvPr id="35" name="Rectangle 34"/>
+          <p:cNvSpPr/>
+          <p:nvPr/>
+        </p:nvSpPr>
+        <p:spPr>
+          <a:xfrm>
+            <a:off x="7279920" y="936000"/>
+            <a:ext cx="2294640" cy="540000"/>
+          </a:xfrm>
+          <a:prstGeom prst="rect">
+            <a:avLst/>
+          </a:prstGeom>
+          <a:solidFill>
+            <a:srgbClr val="1F78B4"/>
+          </a:solidFill>
+          <a:ln>
+            <a:noFill/>
+          </a:ln>
+        </p:spPr>
+        <p:style>
+          <a:lnRef idx="1">
+            <a:schemeClr val="accent1"/>
+          </a:lnRef>
+          <a:fillRef idx="3">
+            <a:schemeClr val="accent1"/>
+          </a:fillRef>
+          <a:effectRef idx="2">
+            <a:schemeClr val="accent1"/>
+          </a:effectRef>
+          <a:fontRef idx="minor">
+            <a:schemeClr val="lt1"/>
+          </a:fontRef>
+        </p:style>
+        <p:txBody>
+          <a:bodyPr rtlCol="0" anchor="ctr"/>
+          <a:lstStyle/>
+          <a:p>
+            <a:pPr algn="ctr"/>
+          </a:p>
+        </p:txBody>
+      </p:sp>
+      <p:sp>
+        <p:nvSpPr>
+          <p:cNvPr id="36" name="TextBox 35"/>
+          <p:cNvSpPr txBox="1"/>
+          <p:nvPr/>
+        </p:nvSpPr>
+        <p:spPr>
+          <a:xfrm>
+            <a:off x="7315920" y="972000"/>
+            <a:ext cx="2258640" cy="468000"/>
+          </a:xfrm>
+          <a:prstGeom prst="rect">
+            <a:avLst/>
+          </a:prstGeom>
+          <a:noFill/>
+        </p:spPr>
+        <p:txBody>
+          <a:bodyPr wrap="none">
+            <a:spAutoFit/>
+          </a:bodyPr>
+          <a:lstStyle/>
+          <a:p>
+            <a:pPr algn="ctr"/>
+            <a:r>
+              <a:rPr sz="1300" b="1">
+                <a:solidFill>
+                  <a:srgbClr val="FFFFFF"/>
+                </a:solidFill>
+                <a:latin typeface="IPAゴシック"/>
+              </a:rPr>
+              <a:t>■ GMARCH</a:t>
+            </a:r>
+          </a:p>
+        </p:txBody>
+      </p:sp>
+      <p:sp>
+        <p:nvSpPr>
+          <p:cNvPr id="37" name="Rectangle 36"/>
+          <p:cNvSpPr/>
+          <p:nvPr/>
+        </p:nvSpPr>
+        <p:spPr>
+          <a:xfrm>
+            <a:off x="7315920" y="1548000"/>
+            <a:ext cx="2258640" cy="540000"/>
+          </a:xfrm>
+          <a:prstGeom prst="rect">
+            <a:avLst/>
+          </a:prstGeom>
+          <a:solidFill>
+            <a:srgbClr val="FFFFFF"/>
+          </a:solidFill>
+          <a:ln w="12700">
+            <a:solidFill>
+              <a:srgbClr val="1F78B4"/>
+            </a:solidFill>
+          </a:ln>
+        </p:spPr>
+        <p:style>
+          <a:lnRef idx="1">
+            <a:schemeClr val="accent1"/>
+          </a:lnRef>
+          <a:fillRef idx="3">
+            <a:schemeClr val="accent1"/>
+          </a:fillRef>
+          <a:effectRef idx="2">
+            <a:schemeClr val="accent1"/>
+          </a:effectRef>
+          <a:fontRef idx="minor">
+            <a:schemeClr val="lt1"/>
+          </a:fontRef>
+        </p:style>
+        <p:txBody>
+          <a:bodyPr rtlCol="0" anchor="ctr"/>
+          <a:lstStyle/>
+          <a:p>
+            <a:pPr algn="ctr"/>
+          </a:p>
+        </p:txBody>
+      </p:sp>
+      <p:sp>
+        <p:nvSpPr>
+          <p:cNvPr id="38" name="TextBox 37"/>
+          <p:cNvSpPr txBox="1"/>
+          <p:nvPr/>
+        </p:nvSpPr>
+        <p:spPr>
+          <a:xfrm>
+            <a:off x="7351920" y="1584000"/>
+            <a:ext cx="2186640" cy="468000"/>
+          </a:xfrm>
+          <a:prstGeom prst="rect">
+            <a:avLst/>
+          </a:prstGeom>
+          <a:noFill/>
+        </p:spPr>
+        <p:txBody>
+          <a:bodyPr wrap="none">
+            <a:spAutoFit/>
+          </a:bodyPr>
+          <a:lstStyle/>
+          <a:p>
+            <a:pPr algn="ctr"/>
+            <a:r>
+              <a:rPr sz="1300" b="1">
+                <a:solidFill>
+                  <a:srgbClr val="1F3564"/>
+                </a:solidFill>
+                <a:latin typeface="IPAゴシック"/>
+              </a:rPr>
+              <a:t>学習院大学</a:t>
+            </a:r>
+          </a:p>
+        </p:txBody>
+      </p:sp>
+      <p:sp>
+        <p:nvSpPr>
+          <p:cNvPr id="39" name="Rectangle 38"/>
+          <p:cNvSpPr/>
+          <p:nvPr/>
+        </p:nvSpPr>
+        <p:spPr>
+          <a:xfrm>
+            <a:off x="7315920" y="2142000"/>
+            <a:ext cx="2258640" cy="540000"/>
+          </a:xfrm>
+          <a:prstGeom prst="rect">
+            <a:avLst/>
+          </a:prstGeom>
+          <a:solidFill>
+            <a:srgbClr val="FFFFFF"/>
+          </a:solidFill>
+          <a:ln w="12700">
+            <a:solidFill>
+              <a:srgbClr val="1F78B4"/>
+            </a:solidFill>
+          </a:ln>
+        </p:spPr>
+        <p:style>
+          <a:lnRef idx="1">
+            <a:schemeClr val="accent1"/>
+          </a:lnRef>
+          <a:fillRef idx="3">
+            <a:schemeClr val="accent1"/>
+          </a:fillRef>
+          <a:effectRef idx="2">
+            <a:schemeClr val="accent1"/>
+          </a:effectRef>
+          <a:fontRef idx="minor">
+            <a:schemeClr val="lt1"/>
+          </a:fontRef>
+        </p:style>
+        <p:txBody>
+          <a:bodyPr rtlCol="0" anchor="ctr"/>
+          <a:lstStyle/>
+          <a:p>
+            <a:pPr algn="ctr"/>
+          </a:p>
+        </p:txBody>
+      </p:sp>
+      <p:sp>
+        <p:nvSpPr>
+          <p:cNvPr id="40" name="TextBox 39"/>
+          <p:cNvSpPr txBox="1"/>
+          <p:nvPr/>
+        </p:nvSpPr>
+        <p:spPr>
+          <a:xfrm>
+            <a:off x="7351920" y="2178000"/>
+            <a:ext cx="2186640" cy="468000"/>
+          </a:xfrm>
+          <a:prstGeom prst="rect">
+            <a:avLst/>
+          </a:prstGeom>
+          <a:noFill/>
+        </p:spPr>
+        <p:txBody>
+          <a:bodyPr wrap="none">
+            <a:spAutoFit/>
+          </a:bodyPr>
+          <a:lstStyle/>
+          <a:p>
+            <a:pPr algn="ctr"/>
+            <a:r>
+              <a:rPr sz="1300" b="1">
+                <a:solidFill>
+                  <a:srgbClr val="1F3564"/>
+                </a:solidFill>
+                <a:latin typeface="IPAゴシック"/>
+              </a:rPr>
+              <a:t>明治大学</a:t>
+            </a:r>
+          </a:p>
+        </p:txBody>
+      </p:sp>
+      <p:sp>
+        <p:nvSpPr>
+          <p:cNvPr id="41" name="Rectangle 40"/>
+          <p:cNvSpPr/>
+          <p:nvPr/>
+        </p:nvSpPr>
+        <p:spPr>
+          <a:xfrm>
+            <a:off x="7315920" y="2736000"/>
+            <a:ext cx="2258640" cy="540000"/>
+          </a:xfrm>
+          <a:prstGeom prst="rect">
+            <a:avLst/>
+          </a:prstGeom>
+          <a:solidFill>
+            <a:srgbClr val="FFFFFF"/>
+          </a:solidFill>
+          <a:ln w="12700">
+            <a:solidFill>
+              <a:srgbClr val="1F78B4"/>
+            </a:solidFill>
+          </a:ln>
+        </p:spPr>
+        <p:style>
+          <a:lnRef idx="1">
+            <a:schemeClr val="accent1"/>
+          </a:lnRef>
+          <a:fillRef idx="3">
+            <a:schemeClr val="accent1"/>
+          </a:fillRef>
+          <a:effectRef idx="2">
+            <a:schemeClr val="accent1"/>
+          </a:effectRef>
+          <a:fontRef idx="minor">
+            <a:schemeClr val="lt1"/>
+          </a:fontRef>
+        </p:style>
+        <p:txBody>
+          <a:bodyPr rtlCol="0" anchor="ctr"/>
+          <a:lstStyle/>
+          <a:p>
+            <a:pPr algn="ctr"/>
+          </a:p>
+        </p:txBody>
+      </p:sp>
+      <p:sp>
+        <p:nvSpPr>
+          <p:cNvPr id="42" name="TextBox 41"/>
+          <p:cNvSpPr txBox="1"/>
+          <p:nvPr/>
+        </p:nvSpPr>
+        <p:spPr>
+          <a:xfrm>
+            <a:off x="7351920" y="2772000"/>
+            <a:ext cx="2186640" cy="468000"/>
+          </a:xfrm>
+          <a:prstGeom prst="rect">
+            <a:avLst/>
+          </a:prstGeom>
+          <a:noFill/>
+        </p:spPr>
+        <p:txBody>
+          <a:bodyPr wrap="none">
+            <a:spAutoFit/>
+          </a:bodyPr>
+          <a:lstStyle/>
+          <a:p>
+            <a:pPr algn="ctr"/>
+            <a:r>
+              <a:rPr sz="1300" b="1">
+                <a:solidFill>
+                  <a:srgbClr val="1F3564"/>
+                </a:solidFill>
+                <a:latin typeface="IPAゴシック"/>
+              </a:rPr>
+              <a:t>青山学院大学</a:t>
+            </a:r>
+          </a:p>
+        </p:txBody>
+      </p:sp>
+      <p:sp>
+        <p:nvSpPr>
+          <p:cNvPr id="43" name="Rectangle 42"/>
+          <p:cNvSpPr/>
+          <p:nvPr/>
+        </p:nvSpPr>
+        <p:spPr>
+          <a:xfrm>
+            <a:off x="7315920" y="3330000"/>
+            <a:ext cx="2258640" cy="540000"/>
+          </a:xfrm>
+          <a:prstGeom prst="rect">
+            <a:avLst/>
+          </a:prstGeom>
+          <a:solidFill>
+            <a:srgbClr val="FFFFFF"/>
+          </a:solidFill>
+          <a:ln w="12700">
+            <a:solidFill>
+              <a:srgbClr val="1F78B4"/>
+            </a:solidFill>
+          </a:ln>
+        </p:spPr>
+        <p:style>
+          <a:lnRef idx="1">
+            <a:schemeClr val="accent1"/>
+          </a:lnRef>
+          <a:fillRef idx="3">
+            <a:schemeClr val="accent1"/>
+          </a:fillRef>
+          <a:effectRef idx="2">
+            <a:schemeClr val="accent1"/>
+          </a:effectRef>
+          <a:fontRef idx="minor">
+            <a:schemeClr val="lt1"/>
+          </a:fontRef>
+        </p:style>
+        <p:txBody>
+          <a:bodyPr rtlCol="0" anchor="ctr"/>
+          <a:lstStyle/>
+          <a:p>
+            <a:pPr algn="ctr"/>
+          </a:p>
+        </p:txBody>
+      </p:sp>
+      <p:sp>
+        <p:nvSpPr>
+          <p:cNvPr id="44" name="TextBox 43"/>
+          <p:cNvSpPr txBox="1"/>
+          <p:nvPr/>
+        </p:nvSpPr>
+        <p:spPr>
+          <a:xfrm>
+            <a:off x="7351920" y="3366000"/>
+            <a:ext cx="2186640" cy="468000"/>
+          </a:xfrm>
+          <a:prstGeom prst="rect">
+            <a:avLst/>
+          </a:prstGeom>
+          <a:noFill/>
+        </p:spPr>
+        <p:txBody>
+          <a:bodyPr wrap="none">
+            <a:spAutoFit/>
+          </a:bodyPr>
+          <a:lstStyle/>
+          <a:p>
+            <a:pPr algn="ctr"/>
+            <a:r>
+              <a:rPr sz="1300" b="1">
+                <a:solidFill>
+                  <a:srgbClr val="1F3564"/>
+                </a:solidFill>
+                <a:latin typeface="IPAゴシック"/>
+              </a:rPr>
+              <a:t>立教大学</a:t>
+            </a:r>
+          </a:p>
+        </p:txBody>
+      </p:sp>
+      <p:sp>
+        <p:nvSpPr>
+          <p:cNvPr id="45" name="Rectangle 44"/>
+          <p:cNvSpPr/>
+          <p:nvPr/>
+        </p:nvSpPr>
+        <p:spPr>
+          <a:xfrm>
+            <a:off x="7315920" y="3924000"/>
+            <a:ext cx="2258640" cy="540000"/>
+          </a:xfrm>
+          <a:prstGeom prst="rect">
+            <a:avLst/>
+          </a:prstGeom>
+          <a:solidFill>
+            <a:srgbClr val="FFFFFF"/>
+          </a:solidFill>
+          <a:ln w="12700">
+            <a:solidFill>
+              <a:srgbClr val="1F78B4"/>
+            </a:solidFill>
+          </a:ln>
+        </p:spPr>
+        <p:style>
+          <a:lnRef idx="1">
+            <a:schemeClr val="accent1"/>
+          </a:lnRef>
+          <a:fillRef idx="3">
+            <a:schemeClr val="accent1"/>
+          </a:fillRef>
+          <a:effectRef idx="2">
+            <a:schemeClr val="accent1"/>
+          </a:effectRef>
+          <a:fontRef idx="minor">
+            <a:schemeClr val="lt1"/>
+          </a:fontRef>
+        </p:style>
+        <p:txBody>
+          <a:bodyPr rtlCol="0" anchor="ctr"/>
+          <a:lstStyle/>
+          <a:p>
+            <a:pPr algn="ctr"/>
+          </a:p>
+        </p:txBody>
+      </p:sp>
+      <p:sp>
+        <p:nvSpPr>
+          <p:cNvPr id="46" name="TextBox 45"/>
+          <p:cNvSpPr txBox="1"/>
+          <p:nvPr/>
+        </p:nvSpPr>
+        <p:spPr>
+          <a:xfrm>
+            <a:off x="7351920" y="3960000"/>
+            <a:ext cx="2186640" cy="468000"/>
+          </a:xfrm>
+          <a:prstGeom prst="rect">
+            <a:avLst/>
+          </a:prstGeom>
+          <a:noFill/>
+        </p:spPr>
+        <p:txBody>
+          <a:bodyPr wrap="none">
+            <a:spAutoFit/>
+          </a:bodyPr>
+          <a:lstStyle/>
+          <a:p>
+            <a:pPr algn="ctr"/>
+            <a:r>
+              <a:rPr sz="1300" b="1">
+                <a:solidFill>
+                  <a:srgbClr val="1F3564"/>
+                </a:solidFill>
+                <a:latin typeface="IPAゴシック"/>
+              </a:rPr>
+              <a:t>中央大学</a:t>
+            </a:r>
+          </a:p>
+        </p:txBody>
+      </p:sp>
+      <p:sp>
+        <p:nvSpPr>
+          <p:cNvPr id="47" name="Rectangle 46"/>
+          <p:cNvSpPr/>
+          <p:nvPr/>
+        </p:nvSpPr>
+        <p:spPr>
+          <a:xfrm>
+            <a:off x="7315920" y="4518000"/>
+            <a:ext cx="2258640" cy="540000"/>
+          </a:xfrm>
+          <a:prstGeom prst="rect">
+            <a:avLst/>
+          </a:prstGeom>
+          <a:solidFill>
+            <a:srgbClr val="FFFFFF"/>
+          </a:solidFill>
+          <a:ln w="12700">
+            <a:solidFill>
+              <a:srgbClr val="1F78B4"/>
+            </a:solidFill>
+          </a:ln>
+        </p:spPr>
+        <p:style>
+          <a:lnRef idx="1">
+            <a:schemeClr val="accent1"/>
+          </a:lnRef>
+          <a:fillRef idx="3">
+            <a:schemeClr val="accent1"/>
+          </a:fillRef>
+          <a:effectRef idx="2">
+            <a:schemeClr val="accent1"/>
+          </a:effectRef>
+          <a:fontRef idx="minor">
+            <a:schemeClr val="lt1"/>
+          </a:fontRef>
+        </p:style>
+        <p:txBody>
+          <a:bodyPr rtlCol="0" anchor="ctr"/>
+          <a:lstStyle/>
+          <a:p>
+            <a:pPr algn="ctr"/>
+          </a:p>
+        </p:txBody>
+      </p:sp>
+      <p:sp>
+        <p:nvSpPr>
+          <p:cNvPr id="48" name="TextBox 47"/>
+          <p:cNvSpPr txBox="1"/>
+          <p:nvPr/>
+        </p:nvSpPr>
+        <p:spPr>
+          <a:xfrm>
+            <a:off x="7351920" y="4554000"/>
+            <a:ext cx="2186640" cy="468000"/>
+          </a:xfrm>
+          <a:prstGeom prst="rect">
+            <a:avLst/>
+          </a:prstGeom>
+          <a:noFill/>
+        </p:spPr>
+        <p:txBody>
+          <a:bodyPr wrap="none">
+            <a:spAutoFit/>
+          </a:bodyPr>
+          <a:lstStyle/>
+          <a:p>
+            <a:pPr algn="ctr"/>
+            <a:r>
+              <a:rPr sz="1300" b="1">
+                <a:solidFill>
+                  <a:srgbClr val="1F3564"/>
+                </a:solidFill>
+                <a:latin typeface="IPAゴシック"/>
+              </a:rPr>
+              <a:t>法政大学</a:t>
+            </a:r>
+          </a:p>
+        </p:txBody>
+      </p:sp>
+      <p:sp>
+        <p:nvSpPr>
+          <p:cNvPr id="49" name="Rectangle 48"/>
+          <p:cNvSpPr/>
+          <p:nvPr/>
+        </p:nvSpPr>
+        <p:spPr>
+          <a:xfrm>
+            <a:off x="9646560" y="936000"/>
+            <a:ext cx="2294640" cy="540000"/>
+          </a:xfrm>
+          <a:prstGeom prst="rect">
+            <a:avLst/>
+          </a:prstGeom>
+          <a:solidFill>
+            <a:srgbClr val="27AE60"/>
+          </a:solidFill>
+          <a:ln>
+            <a:noFill/>
+          </a:ln>
+        </p:spPr>
+        <p:style>
+          <a:lnRef idx="1">
+            <a:schemeClr val="accent1"/>
+          </a:lnRef>
+          <a:fillRef idx="3">
+            <a:schemeClr val="accent1"/>
+          </a:fillRef>
+          <a:effectRef idx="2">
+            <a:schemeClr val="accent1"/>
+          </a:effectRef>
+          <a:fontRef idx="minor">
+            <a:schemeClr val="lt1"/>
+          </a:fontRef>
+        </p:style>
+        <p:txBody>
+          <a:bodyPr rtlCol="0" anchor="ctr"/>
+          <a:lstStyle/>
+          <a:p>
+            <a:pPr algn="ctr"/>
+          </a:p>
+        </p:txBody>
+      </p:sp>
+      <p:sp>
+        <p:nvSpPr>
+          <p:cNvPr id="50" name="TextBox 49"/>
+          <p:cNvSpPr txBox="1"/>
+          <p:nvPr/>
+        </p:nvSpPr>
+        <p:spPr>
+          <a:xfrm>
+            <a:off x="9682560" y="972000"/>
+            <a:ext cx="2258640" cy="468000"/>
+          </a:xfrm>
+          <a:prstGeom prst="rect">
+            <a:avLst/>
+          </a:prstGeom>
+          <a:noFill/>
+        </p:spPr>
+        <p:txBody>
+          <a:bodyPr wrap="none">
+            <a:spAutoFit/>
+          </a:bodyPr>
+          <a:lstStyle/>
+          <a:p>
+            <a:pPr algn="ctr"/>
+            <a:r>
+              <a:rPr sz="1300" b="1">
+                <a:solidFill>
+                  <a:srgbClr val="FFFFFF"/>
+                </a:solidFill>
+                <a:latin typeface="IPAゴシック"/>
+              </a:rPr>
+              <a:t>■ 関関同立</a:t>
+            </a:r>
+          </a:p>
+        </p:txBody>
+      </p:sp>
+      <p:sp>
+        <p:nvSpPr>
+          <p:cNvPr id="51" name="Rectangle 50"/>
+          <p:cNvSpPr/>
+          <p:nvPr/>
+        </p:nvSpPr>
+        <p:spPr>
+          <a:xfrm>
+            <a:off x="9682560" y="1548000"/>
+            <a:ext cx="2258640" cy="540000"/>
+          </a:xfrm>
+          <a:prstGeom prst="rect">
+            <a:avLst/>
+          </a:prstGeom>
+          <a:solidFill>
+            <a:srgbClr val="FFFFFF"/>
+          </a:solidFill>
+          <a:ln w="12700">
+            <a:solidFill>
+              <a:srgbClr val="27AE60"/>
+            </a:solidFill>
+          </a:ln>
+        </p:spPr>
+        <p:style>
+          <a:lnRef idx="1">
+            <a:schemeClr val="accent1"/>
+          </a:lnRef>
+          <a:fillRef idx="3">
+            <a:schemeClr val="accent1"/>
+          </a:fillRef>
+          <a:effectRef idx="2">
+            <a:schemeClr val="accent1"/>
+          </a:effectRef>
+          <a:fontRef idx="minor">
+            <a:schemeClr val="lt1"/>
+          </a:fontRef>
+        </p:style>
+        <p:txBody>
+          <a:bodyPr rtlCol="0" anchor="ctr"/>
+          <a:lstStyle/>
+          <a:p>
+            <a:pPr algn="ctr"/>
+          </a:p>
+        </p:txBody>
+      </p:sp>
+      <p:sp>
+        <p:nvSpPr>
+          <p:cNvPr id="52" name="TextBox 51"/>
+          <p:cNvSpPr txBox="1"/>
+          <p:nvPr/>
+        </p:nvSpPr>
+        <p:spPr>
+          <a:xfrm>
+            <a:off x="9718560" y="1584000"/>
+            <a:ext cx="2186640" cy="468000"/>
+          </a:xfrm>
+          <a:prstGeom prst="rect">
+            <a:avLst/>
+          </a:prstGeom>
+          <a:noFill/>
+        </p:spPr>
+        <p:txBody>
+          <a:bodyPr wrap="none">
+            <a:spAutoFit/>
+          </a:bodyPr>
+          <a:lstStyle/>
+          <a:p>
+            <a:pPr algn="ctr"/>
+            <a:r>
+              <a:rPr sz="1300" b="1">
+                <a:solidFill>
+                  <a:srgbClr val="1F3564"/>
+                </a:solidFill>
+                <a:latin typeface="IPAゴシック"/>
+              </a:rPr>
+              <a:t>関西大学</a:t>
+            </a:r>
+          </a:p>
+        </p:txBody>
+      </p:sp>
+      <p:sp>
+        <p:nvSpPr>
+          <p:cNvPr id="53" name="Rectangle 52"/>
+          <p:cNvSpPr/>
+          <p:nvPr/>
+        </p:nvSpPr>
+        <p:spPr>
+          <a:xfrm>
+            <a:off x="9682560" y="2142000"/>
+            <a:ext cx="2258640" cy="540000"/>
+          </a:xfrm>
+          <a:prstGeom prst="rect">
+            <a:avLst/>
+          </a:prstGeom>
+          <a:solidFill>
+            <a:srgbClr val="FFFFFF"/>
+          </a:solidFill>
+          <a:ln w="12700">
+            <a:solidFill>
+              <a:srgbClr val="27AE60"/>
+            </a:solidFill>
+          </a:ln>
+        </p:spPr>
+        <p:style>
+          <a:lnRef idx="1">
+            <a:schemeClr val="accent1"/>
+          </a:lnRef>
+          <a:fillRef idx="3">
+            <a:schemeClr val="accent1"/>
+          </a:fillRef>
+          <a:effectRef idx="2">
+            <a:schemeClr val="accent1"/>
+          </a:effectRef>
+          <a:fontRef idx="minor">
+            <a:schemeClr val="lt1"/>
+          </a:fontRef>
+        </p:style>
+        <p:txBody>
+          <a:bodyPr rtlCol="0" anchor="ctr"/>
+          <a:lstStyle/>
+          <a:p>
+            <a:pPr algn="ctr"/>
+          </a:p>
+        </p:txBody>
+      </p:sp>
+      <p:sp>
+        <p:nvSpPr>
+          <p:cNvPr id="54" name="TextBox 53"/>
+          <p:cNvSpPr txBox="1"/>
+          <p:nvPr/>
+        </p:nvSpPr>
+        <p:spPr>
+          <a:xfrm>
+            <a:off x="9718560" y="2178000"/>
+            <a:ext cx="2186640" cy="468000"/>
+          </a:xfrm>
+          <a:prstGeom prst="rect">
+            <a:avLst/>
+          </a:prstGeom>
+          <a:noFill/>
+        </p:spPr>
+        <p:txBody>
+          <a:bodyPr wrap="none">
+            <a:spAutoFit/>
+          </a:bodyPr>
+          <a:lstStyle/>
+          <a:p>
+            <a:pPr algn="ctr"/>
+            <a:r>
+              <a:rPr sz="1300" b="1">
+                <a:solidFill>
+                  <a:srgbClr val="1F3564"/>
+                </a:solidFill>
+                <a:latin typeface="IPAゴシック"/>
+              </a:rPr>
+              <a:t>関西学院大学</a:t>
+            </a:r>
+          </a:p>
+        </p:txBody>
+      </p:sp>
+      <p:sp>
+        <p:nvSpPr>
+          <p:cNvPr id="55" name="Rectangle 54"/>
+          <p:cNvSpPr/>
+          <p:nvPr/>
+        </p:nvSpPr>
+        <p:spPr>
+          <a:xfrm>
+            <a:off x="9682560" y="2736000"/>
+            <a:ext cx="2258640" cy="540000"/>
+          </a:xfrm>
+          <a:prstGeom prst="rect">
+            <a:avLst/>
+          </a:prstGeom>
+          <a:solidFill>
+            <a:srgbClr val="FFFFFF"/>
+          </a:solidFill>
+          <a:ln w="12700">
+            <a:solidFill>
+              <a:srgbClr val="27AE60"/>
+            </a:solidFill>
+          </a:ln>
+        </p:spPr>
+        <p:style>
+          <a:lnRef idx="1">
+            <a:schemeClr val="accent1"/>
+          </a:lnRef>
+          <a:fillRef idx="3">
+            <a:schemeClr val="accent1"/>
+          </a:fillRef>
+          <a:effectRef idx="2">
+            <a:schemeClr val="accent1"/>
+          </a:effectRef>
+          <a:fontRef idx="minor">
+            <a:schemeClr val="lt1"/>
+          </a:fontRef>
+        </p:style>
+        <p:txBody>
+          <a:bodyPr rtlCol="0" anchor="ctr"/>
+          <a:lstStyle/>
+          <a:p>
+            <a:pPr algn="ctr"/>
+          </a:p>
+        </p:txBody>
+      </p:sp>
+      <p:sp>
+        <p:nvSpPr>
+          <p:cNvPr id="56" name="TextBox 55"/>
+          <p:cNvSpPr txBox="1"/>
+          <p:nvPr/>
+        </p:nvSpPr>
+        <p:spPr>
+          <a:xfrm>
+            <a:off x="9718560" y="2772000"/>
+            <a:ext cx="2186640" cy="468000"/>
+          </a:xfrm>
+          <a:prstGeom prst="rect">
+            <a:avLst/>
+          </a:prstGeom>
+          <a:noFill/>
+        </p:spPr>
+        <p:txBody>
+          <a:bodyPr wrap="none">
+            <a:spAutoFit/>
+          </a:bodyPr>
+          <a:lstStyle/>
+          <a:p>
+            <a:pPr algn="ctr"/>
+            <a:r>
+              <a:rPr sz="1300" b="1">
+                <a:solidFill>
+                  <a:srgbClr val="1F3564"/>
+                </a:solidFill>
+                <a:latin typeface="IPAゴシック"/>
+              </a:rPr>
+              <a:t>同志社大学</a:t>
+            </a:r>
+          </a:p>
+        </p:txBody>
+      </p:sp>
+      <p:sp>
+        <p:nvSpPr>
+          <p:cNvPr id="57" name="Rectangle 56"/>
+          <p:cNvSpPr/>
+          <p:nvPr/>
+        </p:nvSpPr>
+        <p:spPr>
+          <a:xfrm>
+            <a:off x="9682560" y="3330000"/>
+            <a:ext cx="2258640" cy="540000"/>
+          </a:xfrm>
+          <a:prstGeom prst="rect">
+            <a:avLst/>
+          </a:prstGeom>
+          <a:solidFill>
+            <a:srgbClr val="FFFFFF"/>
+          </a:solidFill>
+          <a:ln w="12700">
+            <a:solidFill>
+              <a:srgbClr val="27AE60"/>
+            </a:solidFill>
+          </a:ln>
+        </p:spPr>
+        <p:style>
+          <a:lnRef idx="1">
+            <a:schemeClr val="accent1"/>
+          </a:lnRef>
+          <a:fillRef idx="3">
+            <a:schemeClr val="accent1"/>
+          </a:fillRef>
+          <a:effectRef idx="2">
+            <a:schemeClr val="accent1"/>
+          </a:effectRef>
+          <a:fontRef idx="minor">
+            <a:schemeClr val="lt1"/>
+          </a:fontRef>
+        </p:style>
+        <p:txBody>
+          <a:bodyPr rtlCol="0" anchor="ctr"/>
+          <a:lstStyle/>
+          <a:p>
+            <a:pPr algn="ctr"/>
+          </a:p>
+        </p:txBody>
+      </p:sp>
+      <p:sp>
+        <p:nvSpPr>
+          <p:cNvPr id="58" name="TextBox 57"/>
+          <p:cNvSpPr txBox="1"/>
+          <p:nvPr/>
+        </p:nvSpPr>
+        <p:spPr>
+          <a:xfrm>
+            <a:off x="9718560" y="3366000"/>
+            <a:ext cx="2186640" cy="468000"/>
+          </a:xfrm>
+          <a:prstGeom prst="rect">
+            <a:avLst/>
+          </a:prstGeom>
+          <a:noFill/>
+        </p:spPr>
+        <p:txBody>
+          <a:bodyPr wrap="none">
+            <a:spAutoFit/>
+          </a:bodyPr>
+          <a:lstStyle/>
+          <a:p>
+            <a:pPr algn="ctr"/>
+            <a:r>
+              <a:rPr sz="1300" b="1">
+                <a:solidFill>
+                  <a:srgbClr val="1F3564"/>
+                </a:solidFill>
+                <a:latin typeface="IPAゴシック"/>
+              </a:rPr>
+              <a:t>立命館大学</a:t>
+            </a:r>
+          </a:p>
+        </p:txBody>
+      </p:sp>
+    </p:spTree>
+  </p:cSld>
+  <p:clrMapOvr>
+    <a:masterClrMapping/>
+  </p:clrMapOvr>
+</p:sld>
+</file>
+
+<file path=ppt/slides/slide3.xml><?xml version="1.0" encoding="utf-8"?>
 <p:sld xmlns:a="http://schemas.openxmlformats.org/drawingml/2006/main" xmlns:p="http://schemas.openxmlformats.org/presentationml/2006/main" xmlns:r="http://schemas.openxmlformats.org/officeDocument/2006/relationships">
   <p:cSld>
     <p:spTree>
@@ -5223,203 +7513,6 @@
 </p:sld>
 </file>
 
-<file path=ppt/slides/slide3.xml><?xml version="1.0" encoding="utf-8"?>
-<p:sld xmlns:a="http://schemas.openxmlformats.org/drawingml/2006/main" xmlns:p="http://schemas.openxmlformats.org/presentationml/2006/main" xmlns:r="http://schemas.openxmlformats.org/officeDocument/2006/relationships">
-  <p:cSld>
-    <p:spTree>
-      <p:nvGrpSpPr>
-        <p:cNvPr id="1" name=""/>
-        <p:cNvGrpSpPr/>
-        <p:nvPr/>
-      </p:nvGrpSpPr>
-      <p:grpSpPr/>
-      <p:sp>
-        <p:nvSpPr>
-          <p:cNvPr id="2" name="Rectangle 1"/>
-          <p:cNvSpPr/>
-          <p:nvPr/>
-        </p:nvSpPr>
-        <p:spPr>
-          <a:xfrm>
-            <a:off x="0" y="0"/>
-            <a:ext cx="12193200" cy="6858000"/>
-          </a:xfrm>
-          <a:prstGeom prst="rect">
-            <a:avLst/>
-          </a:prstGeom>
-          <a:solidFill>
-            <a:srgbClr val="F4F6FB"/>
-          </a:solidFill>
-          <a:ln>
-            <a:noFill/>
-          </a:ln>
-        </p:spPr>
-        <p:style>
-          <a:lnRef idx="1">
-            <a:schemeClr val="accent1"/>
-          </a:lnRef>
-          <a:fillRef idx="3">
-            <a:schemeClr val="accent1"/>
-          </a:fillRef>
-          <a:effectRef idx="2">
-            <a:schemeClr val="accent1"/>
-          </a:effectRef>
-          <a:fontRef idx="minor">
-            <a:schemeClr val="lt1"/>
-          </a:fontRef>
-        </p:style>
-        <p:txBody>
-          <a:bodyPr rtlCol="0" anchor="ctr"/>
-          <a:lstStyle/>
-          <a:p>
-            <a:pPr algn="ctr"/>
-          </a:p>
-        </p:txBody>
-      </p:sp>
-      <p:sp>
-        <p:nvSpPr>
-          <p:cNvPr id="3" name="Rectangle 2"/>
-          <p:cNvSpPr/>
-          <p:nvPr/>
-        </p:nvSpPr>
-        <p:spPr>
-          <a:xfrm>
-            <a:off x="0" y="0"/>
-            <a:ext cx="12193200" cy="792000"/>
-          </a:xfrm>
-          <a:prstGeom prst="rect">
-            <a:avLst/>
-          </a:prstGeom>
-          <a:solidFill>
-            <a:srgbClr val="1F3564"/>
-          </a:solidFill>
-          <a:ln>
-            <a:noFill/>
-          </a:ln>
-        </p:spPr>
-        <p:style>
-          <a:lnRef idx="1">
-            <a:schemeClr val="accent1"/>
-          </a:lnRef>
-          <a:fillRef idx="3">
-            <a:schemeClr val="accent1"/>
-          </a:fillRef>
-          <a:effectRef idx="2">
-            <a:schemeClr val="accent1"/>
-          </a:effectRef>
-          <a:fontRef idx="minor">
-            <a:schemeClr val="lt1"/>
-          </a:fontRef>
-        </p:style>
-        <p:txBody>
-          <a:bodyPr rtlCol="0" anchor="ctr"/>
-          <a:lstStyle/>
-          <a:p>
-            <a:pPr algn="ctr"/>
-          </a:p>
-        </p:txBody>
-      </p:sp>
-      <p:sp>
-        <p:nvSpPr>
-          <p:cNvPr id="4" name="TextBox 3"/>
-          <p:cNvSpPr txBox="1"/>
-          <p:nvPr/>
-        </p:nvSpPr>
-        <p:spPr>
-          <a:xfrm>
-            <a:off x="180000" y="0"/>
-            <a:ext cx="11833200" cy="792000"/>
-          </a:xfrm>
-          <a:prstGeom prst="rect">
-            <a:avLst/>
-          </a:prstGeom>
-          <a:noFill/>
-        </p:spPr>
-        <p:txBody>
-          <a:bodyPr wrap="none">
-            <a:spAutoFit/>
-          </a:bodyPr>
-          <a:lstStyle/>
-          <a:p>
-            <a:pPr algn="ctr"/>
-            <a:r>
-              <a:rPr sz="2600" b="1">
-                <a:solidFill>
-                  <a:srgbClr val="FFFFFF"/>
-                </a:solidFill>
-                <a:latin typeface="IPAゴシック"/>
-              </a:rPr>
-              <a:t>選考ファネル：全体応募〜現在の選考状況</a:t>
-            </a:r>
-          </a:p>
-        </p:txBody>
-      </p:sp>
-      <p:sp>
-        <p:nvSpPr>
-          <p:cNvPr id="5" name="TextBox 4"/>
-          <p:cNvSpPr txBox="1"/>
-          <p:nvPr/>
-        </p:nvSpPr>
-        <p:spPr>
-          <a:xfrm>
-            <a:off x="180000" y="864000"/>
-            <a:ext cx="11833200" cy="251999"/>
-          </a:xfrm>
-          <a:prstGeom prst="rect">
-            <a:avLst/>
-          </a:prstGeom>
-          <a:noFill/>
-        </p:spPr>
-        <p:txBody>
-          <a:bodyPr wrap="none">
-            <a:spAutoFit/>
-          </a:bodyPr>
-          <a:lstStyle/>
-          <a:p>
-            <a:r>
-              <a:rPr sz="1200" b="0">
-                <a:solidFill>
-                  <a:srgbClr val="E85D5D"/>
-                </a:solidFill>
-                <a:latin typeface="IPAゴシック"/>
-              </a:rPr>
-              <a:t>※ 現在ほぼ全員が説明会兼WEB選考の選考中フェーズ（2026年1〜7月集計）</a:t>
-            </a:r>
-          </a:p>
-        </p:txBody>
-      </p:sp>
-      <p:pic>
-        <p:nvPicPr>
-          <p:cNvPr id="6" name="Picture 5" descr="funnel.png"/>
-          <p:cNvPicPr>
-            <a:picLocks noChangeAspect="1"/>
-          </p:cNvPicPr>
-          <p:nvPr/>
-        </p:nvPicPr>
-        <p:blipFill>
-          <a:blip r:embed="rId2"/>
-          <a:stretch>
-            <a:fillRect/>
-          </a:stretch>
-        </p:blipFill>
-        <p:spPr>
-          <a:xfrm>
-            <a:off x="720000" y="1224000"/>
-            <a:ext cx="10753200" cy="5418000"/>
-          </a:xfrm>
-          <a:prstGeom prst="rect">
-            <a:avLst/>
-          </a:prstGeom>
-        </p:spPr>
-      </p:pic>
-    </p:spTree>
-  </p:cSld>
-  <p:clrMapOvr>
-    <a:masterClrMapping/>
-  </p:clrMapOvr>
-</p:sld>
-</file>
-
 <file path=ppt/slides/slide4.xml><?xml version="1.0" encoding="utf-8"?>
 <p:sld xmlns:a="http://schemas.openxmlformats.org/drawingml/2006/main" xmlns:p="http://schemas.openxmlformats.org/presentationml/2006/main" xmlns:r="http://schemas.openxmlformats.org/officeDocument/2006/relationships">
   <p:cSld>
@@ -5546,14 +7639,48 @@
                 </a:solidFill>
                 <a:latin typeface="IPAゴシック"/>
               </a:rPr>
-              <a:t>大学グループ別　応募者数</a:t>
+              <a:t>選考ファネル：全体応募〜現在の選考状況</a:t>
+            </a:r>
+          </a:p>
+        </p:txBody>
+      </p:sp>
+      <p:sp>
+        <p:nvSpPr>
+          <p:cNvPr id="5" name="TextBox 4"/>
+          <p:cNvSpPr txBox="1"/>
+          <p:nvPr/>
+        </p:nvSpPr>
+        <p:spPr>
+          <a:xfrm>
+            <a:off x="180000" y="864000"/>
+            <a:ext cx="11833200" cy="251999"/>
+          </a:xfrm>
+          <a:prstGeom prst="rect">
+            <a:avLst/>
+          </a:prstGeom>
+          <a:noFill/>
+        </p:spPr>
+        <p:txBody>
+          <a:bodyPr wrap="none">
+            <a:spAutoFit/>
+          </a:bodyPr>
+          <a:lstStyle/>
+          <a:p>
+            <a:r>
+              <a:rPr sz="1200" b="0">
+                <a:solidFill>
+                  <a:srgbClr val="E85D5D"/>
+                </a:solidFill>
+                <a:latin typeface="IPAゴシック"/>
+              </a:rPr>
+              <a:t>※ 現在ほぼ全員が説明会兼WEB選考の選考中フェーズ（2026年1〜7月集計）</a:t>
             </a:r>
           </a:p>
         </p:txBody>
       </p:sp>
       <p:pic>
         <p:nvPicPr>
-          <p:cNvPr id="5" name="Picture 4" descr="group_bar.png"/>
+          <p:cNvPr id="6" name="Picture 5" descr="funnel.png"/>
           <p:cNvPicPr>
             <a:picLocks noChangeAspect="1"/>
           </p:cNvPicPr>
@@ -5567,125 +7694,14 @@
         </p:blipFill>
         <p:spPr>
           <a:xfrm>
-            <a:off x="180000" y="936000"/>
-            <a:ext cx="7072055" cy="5634000"/>
+            <a:off x="720000" y="1224000"/>
+            <a:ext cx="10753200" cy="5418000"/>
           </a:xfrm>
           <a:prstGeom prst="rect">
             <a:avLst/>
           </a:prstGeom>
         </p:spPr>
       </p:pic>
-      <p:sp>
-        <p:nvSpPr>
-          <p:cNvPr id="6" name="TextBox 5"/>
-          <p:cNvSpPr txBox="1"/>
-          <p:nvPr/>
-        </p:nvSpPr>
-        <p:spPr>
-          <a:xfrm>
-            <a:off x="7315920" y="1080000"/>
-            <a:ext cx="4511484" cy="5346000"/>
-          </a:xfrm>
-          <a:prstGeom prst="rect">
-            <a:avLst/>
-          </a:prstGeom>
-          <a:noFill/>
-        </p:spPr>
-        <p:txBody>
-          <a:bodyPr wrap="square">
-            <a:spAutoFit/>
-          </a:bodyPr>
-          <a:lstStyle/>
-          <a:p>
-            <a:r>
-              <a:rPr sz="1600" b="1">
-                <a:solidFill>
-                  <a:srgbClr val="1F3564"/>
-                </a:solidFill>
-                <a:latin typeface="IPAゴシック"/>
-              </a:rPr>
-              <a:t>【上位校内訳】</a:t>
-            </a:r>
-          </a:p>
-          <a:p>
-            <a:r>
-              <a:rPr sz="1800" b="1">
-                <a:solidFill>
-                  <a:srgbClr val="1F3564"/>
-                </a:solidFill>
-                <a:latin typeface="IPAゴシック"/>
-              </a:rPr>
-              <a:t>関西学院大学　2名</a:t>
-            </a:r>
-          </a:p>
-          <a:p>
-            <a:r>
-              <a:rPr sz="1800" b="1">
-                <a:solidFill>
-                  <a:srgbClr val="1F3564"/>
-                </a:solidFill>
-                <a:latin typeface="IPAゴシック"/>
-              </a:rPr>
-              <a:t>明治大学　　　1名</a:t>
-            </a:r>
-          </a:p>
-          <a:p>
-            <a:r>
-              <a:rPr sz="1800" b="1">
-                <a:solidFill>
-                  <a:srgbClr val="1F3564"/>
-                </a:solidFill>
-                <a:latin typeface="IPAゴシック"/>
-              </a:rPr>
-              <a:t>同志社大学　　1名</a:t>
-            </a:r>
-          </a:p>
-          <a:p>
-            <a:r>
-              <a:rPr sz="600" b="0">
-                <a:solidFill>
-                  <a:srgbClr val="1F3564"/>
-                </a:solidFill>
-                <a:latin typeface="IPAゴシック"/>
-              </a:rPr>
-              <a:t/>
-            </a:r>
-          </a:p>
-          <a:p>
-            <a:r>
-              <a:rPr sz="1400" b="1">
-                <a:solidFill>
-                  <a:srgbClr val="E85D5D"/>
-                </a:solidFill>
-                <a:latin typeface="IPAゴシック"/>
-              </a:rPr>
-              <a:t>【ポイント】</a:t>
-            </a:r>
-          </a:p>
-          <a:p>
-            <a:r>
-              <a:rPr sz="1300" b="0">
-                <a:solidFill>
-                  <a:srgbClr val="1F3564"/>
-                </a:solidFill>
-                <a:latin typeface="IPAゴシック"/>
-              </a:rPr>
-              <a:t>・上位校比率：21%（4名/19名）</a:t>
-            </a:r>
-          </a:p>
-          <a:p>
-            <a:r>
-              <a:rPr sz="1300" b="0">
-                <a:solidFill>
-                  <a:srgbClr val="AAAAAA"/>
-                </a:solidFill>
-                <a:latin typeface="IPAゴシック"/>
-              </a:rPr>
-              <a:t>・旧帝大・早慶は応募なし</a:t>
-            </a:r>
-          </a:p>
-        </p:txBody>
-      </p:sp>
     </p:spTree>
   </p:cSld>
   <p:clrMapOvr>
@@ -5820,14 +7836,14 @@
                 </a:solidFill>
                 <a:latin typeface="IPAゴシック"/>
               </a:rPr>
-              <a:t>上位校　個別大学別　応募者数</a:t>
+              <a:t>大学グループ別　応募者数</a:t>
             </a:r>
           </a:p>
         </p:txBody>
       </p:sp>
       <p:pic>
         <p:nvPicPr>
-          <p:cNvPr id="5" name="Picture 4" descr="univ_bar.png"/>
+          <p:cNvPr id="5" name="Picture 4" descr="group_bar.png"/>
           <p:cNvPicPr>
             <a:picLocks noChangeAspect="1"/>
           </p:cNvPicPr>
@@ -5841,8 +7857,8 @@
         </p:blipFill>
         <p:spPr>
           <a:xfrm>
-            <a:off x="720000" y="1080000"/>
-            <a:ext cx="6706260" cy="5418000"/>
+            <a:off x="180000" y="936000"/>
+            <a:ext cx="7072055" cy="5634000"/>
           </a:xfrm>
           <a:prstGeom prst="rect">
             <a:avLst/>
@@ -5857,8 +7873,8 @@
         </p:nvSpPr>
         <p:spPr>
           <a:xfrm>
-            <a:off x="7193988" y="1224000"/>
-            <a:ext cx="4633416" cy="3240000"/>
+            <a:off x="7315920" y="1080000"/>
+            <a:ext cx="4511484" cy="5346000"/>
           </a:xfrm>
           <a:prstGeom prst="rect">
             <a:avLst/>
@@ -5874,55 +7890,88 @@
             <a:r>
               <a:rPr sz="1600" b="1">
                 <a:solidFill>
-                  <a:srgbClr val="27AE60"/>
+                  <a:srgbClr val="1F3564"/>
                 </a:solidFill>
                 <a:latin typeface="IPAゴシック"/>
               </a:rPr>
-              <a:t>【全員 選考中】</a:t>
-            </a:r>
-          </a:p>
-          <a:p>
-            <a:r>
-              <a:rPr sz="1400" b="1">
+              <a:t>【上位校内訳】</a:t>
+            </a:r>
+          </a:p>
+          <a:p>
+            <a:r>
+              <a:rPr sz="1800" b="1">
                 <a:solidFill>
                   <a:srgbClr val="1F3564"/>
                 </a:solidFill>
                 <a:latin typeface="IPAゴシック"/>
               </a:rPr>
-              <a:t>関西学院大学（経済学部）</a:t>
-            </a:r>
-          </a:p>
-          <a:p>
-            <a:r>
-              <a:rPr sz="1400" b="1">
+              <a:t>関西学院大学　2名</a:t>
+            </a:r>
+          </a:p>
+          <a:p>
+            <a:r>
+              <a:rPr sz="1800" b="1">
                 <a:solidFill>
                   <a:srgbClr val="1F3564"/>
                 </a:solidFill>
                 <a:latin typeface="IPAゴシック"/>
               </a:rPr>
-              <a:t>関西学院大学（文学部）</a:t>
-            </a:r>
-          </a:p>
-          <a:p>
-            <a:r>
-              <a:rPr sz="1400" b="1">
+              <a:t>明治大学　　　1名</a:t>
+            </a:r>
+          </a:p>
+          <a:p>
+            <a:r>
+              <a:rPr sz="1800" b="1">
                 <a:solidFill>
                   <a:srgbClr val="1F3564"/>
                 </a:solidFill>
                 <a:latin typeface="IPAゴシック"/>
               </a:rPr>
-              <a:t>明治大学（商学部）</a:t>
-            </a:r>
-          </a:p>
-          <a:p>
-            <a:r>
-              <a:rPr sz="1400" b="1">
+              <a:t>同志社大学　　1名</a:t>
+            </a:r>
+          </a:p>
+          <a:p>
+            <a:r>
+              <a:rPr sz="600" b="0">
                 <a:solidFill>
                   <a:srgbClr val="1F3564"/>
                 </a:solidFill>
                 <a:latin typeface="IPAゴシック"/>
               </a:rPr>
-              <a:t>同志社大学（文化情報学部）</a:t>
+              <a:t/>
+            </a:r>
+          </a:p>
+          <a:p>
+            <a:r>
+              <a:rPr sz="1400" b="1">
+                <a:solidFill>
+                  <a:srgbClr val="E85D5D"/>
+                </a:solidFill>
+                <a:latin typeface="IPAゴシック"/>
+              </a:rPr>
+              <a:t>【ポイント】</a:t>
+            </a:r>
+          </a:p>
+          <a:p>
+            <a:r>
+              <a:rPr sz="1300" b="0">
+                <a:solidFill>
+                  <a:srgbClr val="1F3564"/>
+                </a:solidFill>
+                <a:latin typeface="IPAゴシック"/>
+              </a:rPr>
+              <a:t>・上位校比率：21%（4名/19名）</a:t>
+            </a:r>
+          </a:p>
+          <a:p>
+            <a:r>
+              <a:rPr sz="1300" b="0">
+                <a:solidFill>
+                  <a:srgbClr val="AAAAAA"/>
+                </a:solidFill>
+                <a:latin typeface="IPAゴシック"/>
+              </a:rPr>
+              <a:t>・旧帝大・早慶・学習院は応募なし</a:t>
             </a:r>
           </a:p>
         </p:txBody>
@@ -5936,6 +7985,247 @@
 </file>
 
 <file path=ppt/slides/slide6.xml><?xml version="1.0" encoding="utf-8"?>
+<p:sld xmlns:a="http://schemas.openxmlformats.org/drawingml/2006/main" xmlns:p="http://schemas.openxmlformats.org/presentationml/2006/main" xmlns:r="http://schemas.openxmlformats.org/officeDocument/2006/relationships">
+  <p:cSld>
+    <p:spTree>
+      <p:nvGrpSpPr>
+        <p:cNvPr id="1" name=""/>
+        <p:cNvGrpSpPr/>
+        <p:nvPr/>
+      </p:nvGrpSpPr>
+      <p:grpSpPr/>
+      <p:sp>
+        <p:nvSpPr>
+          <p:cNvPr id="2" name="Rectangle 1"/>
+          <p:cNvSpPr/>
+          <p:nvPr/>
+        </p:nvSpPr>
+        <p:spPr>
+          <a:xfrm>
+            <a:off x="0" y="0"/>
+            <a:ext cx="12193200" cy="6858000"/>
+          </a:xfrm>
+          <a:prstGeom prst="rect">
+            <a:avLst/>
+          </a:prstGeom>
+          <a:solidFill>
+            <a:srgbClr val="F4F6FB"/>
+          </a:solidFill>
+          <a:ln>
+            <a:noFill/>
+          </a:ln>
+        </p:spPr>
+        <p:style>
+          <a:lnRef idx="1">
+            <a:schemeClr val="accent1"/>
+          </a:lnRef>
+          <a:fillRef idx="3">
+            <a:schemeClr val="accent1"/>
+          </a:fillRef>
+          <a:effectRef idx="2">
+            <a:schemeClr val="accent1"/>
+          </a:effectRef>
+          <a:fontRef idx="minor">
+            <a:schemeClr val="lt1"/>
+          </a:fontRef>
+        </p:style>
+        <p:txBody>
+          <a:bodyPr rtlCol="0" anchor="ctr"/>
+          <a:lstStyle/>
+          <a:p>
+            <a:pPr algn="ctr"/>
+          </a:p>
+        </p:txBody>
+      </p:sp>
+      <p:sp>
+        <p:nvSpPr>
+          <p:cNvPr id="3" name="Rectangle 2"/>
+          <p:cNvSpPr/>
+          <p:nvPr/>
+        </p:nvSpPr>
+        <p:spPr>
+          <a:xfrm>
+            <a:off x="0" y="0"/>
+            <a:ext cx="12193200" cy="792000"/>
+          </a:xfrm>
+          <a:prstGeom prst="rect">
+            <a:avLst/>
+          </a:prstGeom>
+          <a:solidFill>
+            <a:srgbClr val="1F3564"/>
+          </a:solidFill>
+          <a:ln>
+            <a:noFill/>
+          </a:ln>
+        </p:spPr>
+        <p:style>
+          <a:lnRef idx="1">
+            <a:schemeClr val="accent1"/>
+          </a:lnRef>
+          <a:fillRef idx="3">
+            <a:schemeClr val="accent1"/>
+          </a:fillRef>
+          <a:effectRef idx="2">
+            <a:schemeClr val="accent1"/>
+          </a:effectRef>
+          <a:fontRef idx="minor">
+            <a:schemeClr val="lt1"/>
+          </a:fontRef>
+        </p:style>
+        <p:txBody>
+          <a:bodyPr rtlCol="0" anchor="ctr"/>
+          <a:lstStyle/>
+          <a:p>
+            <a:pPr algn="ctr"/>
+          </a:p>
+        </p:txBody>
+      </p:sp>
+      <p:sp>
+        <p:nvSpPr>
+          <p:cNvPr id="4" name="TextBox 3"/>
+          <p:cNvSpPr txBox="1"/>
+          <p:nvPr/>
+        </p:nvSpPr>
+        <p:spPr>
+          <a:xfrm>
+            <a:off x="180000" y="0"/>
+            <a:ext cx="11833200" cy="792000"/>
+          </a:xfrm>
+          <a:prstGeom prst="rect">
+            <a:avLst/>
+          </a:prstGeom>
+          <a:noFill/>
+        </p:spPr>
+        <p:txBody>
+          <a:bodyPr wrap="none">
+            <a:spAutoFit/>
+          </a:bodyPr>
+          <a:lstStyle/>
+          <a:p>
+            <a:pPr algn="ctr"/>
+            <a:r>
+              <a:rPr sz="2600" b="1">
+                <a:solidFill>
+                  <a:srgbClr val="FFFFFF"/>
+                </a:solidFill>
+                <a:latin typeface="IPAゴシック"/>
+              </a:rPr>
+              <a:t>上位校　個別大学別　応募者数</a:t>
+            </a:r>
+          </a:p>
+        </p:txBody>
+      </p:sp>
+      <p:pic>
+        <p:nvPicPr>
+          <p:cNvPr id="5" name="Picture 4" descr="univ_bar.png"/>
+          <p:cNvPicPr>
+            <a:picLocks noChangeAspect="1"/>
+          </p:cNvPicPr>
+          <p:nvPr/>
+        </p:nvPicPr>
+        <p:blipFill>
+          <a:blip r:embed="rId2"/>
+          <a:stretch>
+            <a:fillRect/>
+          </a:stretch>
+        </p:blipFill>
+        <p:spPr>
+          <a:xfrm>
+            <a:off x="720000" y="1080000"/>
+            <a:ext cx="6706260" cy="5418000"/>
+          </a:xfrm>
+          <a:prstGeom prst="rect">
+            <a:avLst/>
+          </a:prstGeom>
+        </p:spPr>
+      </p:pic>
+      <p:sp>
+        <p:nvSpPr>
+          <p:cNvPr id="6" name="TextBox 5"/>
+          <p:cNvSpPr txBox="1"/>
+          <p:nvPr/>
+        </p:nvSpPr>
+        <p:spPr>
+          <a:xfrm>
+            <a:off x="7193988" y="1224000"/>
+            <a:ext cx="4633416" cy="3240000"/>
+          </a:xfrm>
+          <a:prstGeom prst="rect">
+            <a:avLst/>
+          </a:prstGeom>
+          <a:noFill/>
+        </p:spPr>
+        <p:txBody>
+          <a:bodyPr wrap="square">
+            <a:spAutoFit/>
+          </a:bodyPr>
+          <a:lstStyle/>
+          <a:p>
+            <a:r>
+              <a:rPr sz="1600" b="1">
+                <a:solidFill>
+                  <a:srgbClr val="27AE60"/>
+                </a:solidFill>
+                <a:latin typeface="IPAゴシック"/>
+              </a:rPr>
+              <a:t>【全員 選考中】</a:t>
+            </a:r>
+          </a:p>
+          <a:p>
+            <a:r>
+              <a:rPr sz="1400" b="1">
+                <a:solidFill>
+                  <a:srgbClr val="1F3564"/>
+                </a:solidFill>
+                <a:latin typeface="IPAゴシック"/>
+              </a:rPr>
+              <a:t>関西学院大学（経済学部）</a:t>
+            </a:r>
+          </a:p>
+          <a:p>
+            <a:r>
+              <a:rPr sz="1400" b="1">
+                <a:solidFill>
+                  <a:srgbClr val="1F3564"/>
+                </a:solidFill>
+                <a:latin typeface="IPAゴシック"/>
+              </a:rPr>
+              <a:t>関西学院大学（文学部）</a:t>
+            </a:r>
+          </a:p>
+          <a:p>
+            <a:r>
+              <a:rPr sz="1400" b="1">
+                <a:solidFill>
+                  <a:srgbClr val="1F3564"/>
+                </a:solidFill>
+                <a:latin typeface="IPAゴシック"/>
+              </a:rPr>
+              <a:t>明治大学（商学部）</a:t>
+            </a:r>
+          </a:p>
+          <a:p>
+            <a:r>
+              <a:rPr sz="1400" b="1">
+                <a:solidFill>
+                  <a:srgbClr val="1F3564"/>
+                </a:solidFill>
+                <a:latin typeface="IPAゴシック"/>
+              </a:rPr>
+              <a:t>同志社大学（文化情報学部）</a:t>
+            </a:r>
+          </a:p>
+        </p:txBody>
+      </p:sp>
+    </p:spTree>
+  </p:cSld>
+  <p:clrMapOvr>
+    <a:masterClrMapping/>
+  </p:clrMapOvr>
+</p:sld>
+</file>
+
+<file path=ppt/slides/slide7.xml><?xml version="1.0" encoding="utf-8"?>
 <p:sld xmlns:a="http://schemas.openxmlformats.org/drawingml/2006/main" xmlns:p="http://schemas.openxmlformats.org/presentationml/2006/main" xmlns:r="http://schemas.openxmlformats.org/officeDocument/2006/relationships">
   <p:cSld>
     <p:spTree>
@@ -6764,7 +9054,7 @@
 </p:sld>
 </file>
 
-<file path=ppt/slides/slide7.xml><?xml version="1.0" encoding="utf-8"?>
+<file path=ppt/slides/slide8.xml><?xml version="1.0" encoding="utf-8"?>
 <p:sld xmlns:a="http://schemas.openxmlformats.org/drawingml/2006/main" xmlns:p="http://schemas.openxmlformats.org/presentationml/2006/main" xmlns:r="http://schemas.openxmlformats.org/officeDocument/2006/relationships">
   <p:cSld>
     <p:spTree>
@@ -7499,7 +9789,7 @@
 </p:sld>
 </file>
 
-<file path=ppt/slides/slide8.xml><?xml version="1.0" encoding="utf-8"?>
+<file path=ppt/slides/slide9.xml><?xml version="1.0" encoding="utf-8"?>
 <p:sld xmlns:a="http://schemas.openxmlformats.org/drawingml/2006/main" xmlns:p="http://schemas.openxmlformats.org/presentationml/2006/main" xmlns:r="http://schemas.openxmlformats.org/officeDocument/2006/relationships">
   <p:cSld>
     <p:spTree>

</xml_diff>